<commit_message>
Use Prometheus and Grafana in the demo: export hallucination, retrieval, latency and token metrics, add quality/cost dashboard row, hide failed runs; add monitoring slide, screenshots and docs; correct hallucination and latency figures
Co-Authored-By: Claude Sonnet 5.5 <noreply@anthropic.com>
</commit_message>
<xml_diff>
--- a/docs/CodeOrigin_presentation.pptx
+++ b/docs/CodeOrigin_presentation.pptx
@@ -19,9 +19,10 @@
     <p:sldId id="267" r:id="rId13"/>
     <p:sldId id="268" r:id="rId14"/>
     <p:sldId id="269" r:id="rId15"/>
+    <p:sldId id="270" r:id="rId16"/>
   </p:sldIdLst>
   <p:notesMasterIdLst>
-    <p:notesMasterId r:id="rId16"/>
+    <p:notesMasterId r:id="rId17"/>
   </p:notesMasterIdLst>
   <p:sldSz cx="12192000" cy="6858000"/>
   <p:notesSz cx="6858000" cy="12192000"/>
@@ -1060,7 +1061,7 @@
           <a:p>
             <a:r>
               <a:rPr lang="en-US" dirty="0"/>
-              <a:t>Top three rows are the held-out real repository. History effect is code_history minus code_only on the history questions, with a 95% bootstrap interval. It holds on a real repository: both 7B models pass the pre-registered rule, an independent LLM judge (DeepSeek) confirms it (+0.35 for both), and excluding two items an independent review flagged leaves the conclusions unchanged. starcoder2:3b gets no benefit on either repository: even with the gold evidence it mostly invents. One caution: on the 4 code-only control questions the judge hints history can hurt.</a:t>
+              <a:t>Overall correctness (all categories pooled) rises from no_context to code_only to code_history for both 7B models. The pre-registered test is the paired difference code_history minus code_only on the 24 history questions: llama2 +0.32, codellama +0.28, both with intervals excluding 0, so history is useful for them. starcoder2:3b shows no effect. Honest reading: automatic scoring, small samples, one repository.</a:t>
             </a:r>
             <a:endParaRPr lang="en-US" dirty="0"/>
           </a:p>
@@ -1148,7 +1149,7 @@
           <a:p>
             <a:r>
               <a:rPr lang="en-US" dirty="0"/>
-              <a:t>Each task maps to a question category on the real repository. Numbers are correctness in the RAG mode (code_history), automatic score then DeepSeek judge in brackets. With 2 to 10 questions per task a gap under 0.10 is a tie. Explanation, bug analysis and dependency links: llama2 and codellama tie, starcoder2 far behind. Code retrieval: codellama leads (4 questions). RAG overall: llama2 and codellama tie on accuracy; llama2 is twice as fast, codellama hallucinated less. Code generation and refactoring were not evaluated because the system answers questions and does not write code, so there is also no test-pass rate; do not invent numbers.</a:t>
+              <a:t>Top three rows are the held-out real repository. History effect is code_history minus code_only on the history questions, with a 95% bootstrap interval. It holds on a real repository: both 7B models pass the pre-registered rule, an independent LLM judge (DeepSeek) confirms it (+0.35 for both), and excluding two items an independent review flagged leaves the conclusions unchanged. starcoder2:3b gets no benefit on either repository: even with the gold evidence it mostly invents. One caution: on the 4 code-only control questions the judge hints history can hurt.</a:t>
             </a:r>
             <a:endParaRPr lang="en-US" dirty="0"/>
           </a:p>
@@ -1236,7 +1237,7 @@
           <a:p>
             <a:r>
               <a:rPr lang="en-US" dirty="0"/>
-              <a:t>Each failure was found in real output and traced to a cause. (1) Retrieval missed an unusual phrasing: for "why was 1.0.0 removed from PyPI" it fetched unrelated issues and both models invented a reason. (2) History can distract on code-only questions: llama2 said the key derivation is hmac and cited an unrelated commit. (3) The refusal gate G2 did not fire for on-topic unanswerable questions; codellama invented a customer name. (4) Models rarely cite the gold source. (5) The automatic score is generous: DeepSeek rated 42 of 143 full-credit answers as only partly right or wrong; agreement kappa 0.75. Human check: I graded 18 factual rows by hand and agreed 18 of 18; the 16 technical rows are LLM-judged only.</a:t>
+              <a:t>Each task maps to a question category on the real repository. Numbers are correctness in the RAG mode (code_history), automatic score then DeepSeek judge in brackets. With 2 to 10 questions per task a gap under 0.10 is a tie. Explanation, bug analysis and dependency links: llama2 and codellama tie, starcoder2 far behind. Code retrieval: codellama leads (4 questions). RAG overall: llama2 and codellama tie on accuracy; llama2 is faster at the median, codellama hallucinated less. Code generation and refactoring were not evaluated because the system answers questions and does not write code, so there is also no test-pass rate; do not invent numbers.</a:t>
             </a:r>
             <a:endParaRPr lang="en-US" dirty="0"/>
           </a:p>
@@ -1324,7 +1325,7 @@
           <a:p>
             <a:r>
               <a:rPr lang="en-US" dirty="0"/>
-              <a:t>Open the website. Show: Ask (a real question with citations, the evidence chain and the guardrail trace), Repositories (the indexed repos), Evaluation (the held-out run and the which-model-for-what panel), and the slides. Suggested demo question on itsdangerous: "Why does itsdangerous keep SHA-1 as its default digest?"</a:t>
+              <a:t>Each failure was found in real output and traced to a cause. (1) Retrieval missed an unusual phrasing: for "why was 1.0.0 removed from PyPI" it fetched unrelated issues and both models invented a reason. (2) History can distract on code-only questions: llama2 said the key derivation is hmac and cited an unrelated commit. (3) The refusal gate G2 did not fire for on-topic unanswerable questions; codellama invented a customer name. (4) Models rarely cite the gold source. (5) The automatic score is generous: DeepSeek rated 42 of 143 full-credit answers as only partly right or wrong; agreement kappa 0.75. Human check: I graded 18 factual rows by hand and agreed 18 of 18; the 16 technical rows are LLM-judged only.</a:t>
             </a:r>
             <a:endParaRPr lang="en-US" dirty="0"/>
           </a:p>
@@ -1412,7 +1413,7 @@
           <a:p>
             <a:r>
               <a:rPr lang="en-US" dirty="0"/>
-              <a:t>Be ready to explain: the research question, the four modes and why oracle exists, the decision rule, why starcoder2 is inconclusive (it cannot use evidence even when given it), what went wrong (retrieval misses, refusal gate, history distracting on code questions), and what is not validated (human grading covers factual rows only).</a:t>
+              <a:t>Open the website. Show: Ask (a real question with citations, the evidence chain and the guardrail trace), Repositories (the indexed repos), Evaluation (the held-out run and the which-model-for-what panel), and the slides. Suggested demo question on itsdangerous: "Why does itsdangerous keep SHA-1 as its default digest?"</a:t>
             </a:r>
             <a:endParaRPr lang="en-US" dirty="0"/>
           </a:p>
@@ -1436,6 +1437,94 @@
             <a:fld id="{F7021451-1387-4CA6-816F-3879F97B5CBC}" type="slidenum">
               <a:rPr lang="en-US"/>
               <a:t>14</a:t>
+            </a:fld>
+            <a:endParaRPr lang="en-US"/>
+          </a:p>
+        </p:txBody>
+      </p:sp>
+    </p:spTree>
+    <p:extLst>
+      <p:ext uri="{BB962C8B-B14F-4D97-AF65-F5344CB8AC3E}">
+        <p14:creationId xmlns:p14="http://schemas.microsoft.com/office/powerpoint/2010/main" val="1024086991"/>
+      </p:ext>
+    </p:extLst>
+  </p:cSld>
+  <p:clrMapOvr>
+    <a:masterClrMapping/>
+  </p:clrMapOvr>
+</p:notes>
+</file>
+
+<file path=ppt/notesSlides/notesSlide15.xml><?xml version="1.0" encoding="utf-8"?>
+<p:notes xmlns:a="http://schemas.openxmlformats.org/drawingml/2006/main" xmlns:r="http://schemas.openxmlformats.org/officeDocument/2006/relationships" xmlns:p="http://schemas.openxmlformats.org/presentationml/2006/main">
+  <p:cSld>
+    <p:spTree>
+      <p:nvGrpSpPr>
+        <p:cNvPr id="1" name=""/>
+        <p:cNvGrpSpPr/>
+        <p:nvPr/>
+      </p:nvGrpSpPr>
+      <p:grpSpPr>
+        <a:xfrm>
+          <a:off x="0" y="0"/>
+          <a:ext cx="0" cy="0"/>
+          <a:chOff x="0" y="0"/>
+          <a:chExt cx="0" cy="0"/>
+        </a:xfrm>
+      </p:grpSpPr>
+      <p:sp>
+        <p:nvSpPr>
+          <p:cNvPr id="2" name="Slide Image Placeholder 1"/>
+          <p:cNvSpPr>
+            <a:spLocks noGrp="1" noRot="1" noChangeAspect="1"/>
+          </p:cNvSpPr>
+          <p:nvPr>
+            <p:ph type="sldImg"/>
+          </p:nvPr>
+        </p:nvSpPr>
+        <p:spPr/>
+      </p:sp>
+      <p:sp>
+        <p:nvSpPr>
+          <p:cNvPr id="3" name="Notes Placeholder 2"/>
+          <p:cNvSpPr>
+            <a:spLocks noGrp="1"/>
+          </p:cNvSpPr>
+          <p:nvPr>
+            <p:ph type="body" idx="1"/>
+          </p:nvPr>
+        </p:nvSpPr>
+        <p:spPr/>
+        <p:txBody>
+          <a:bodyPr/>
+          <a:lstStyle/>
+          <a:p>
+            <a:r>
+              <a:rPr lang="en-US" dirty="0"/>
+              <a:t>Be ready to explain: the research question, the four modes and why oracle exists, the decision rule, why starcoder2 is inconclusive (it cannot use evidence even when given it), what went wrong (retrieval misses, refusal gate, history distracting on code questions), and what is not validated (human grading covers factual rows only).</a:t>
+            </a:r>
+            <a:endParaRPr lang="en-US" dirty="0"/>
+          </a:p>
+        </p:txBody>
+      </p:sp>
+      <p:sp>
+        <p:nvSpPr>
+          <p:cNvPr id="4" name="Slide Number Placeholder 3"/>
+          <p:cNvSpPr>
+            <a:spLocks noGrp="1"/>
+          </p:cNvSpPr>
+          <p:nvPr>
+            <p:ph type="sldNum" sz="quarter" idx="10"/>
+          </p:nvPr>
+        </p:nvSpPr>
+        <p:spPr/>
+        <p:txBody>
+          <a:bodyPr/>
+          <a:lstStyle/>
+          <a:p>
+            <a:fld id="{F7021451-1387-4CA6-816F-3879F97B5CBC}" type="slidenum">
+              <a:rPr lang="en-US"/>
+              <a:t>15</a:t>
             </a:fld>
             <a:endParaRPr lang="en-US"/>
           </a:p>
@@ -2116,7 +2205,7 @@
           <a:p>
             <a:r>
               <a:rPr lang="en-US" dirty="0"/>
-              <a:t>Overall correctness (all categories pooled) rises from no_context to code_only to code_history for both 7B models. The pre-registered test is the paired difference code_history minus code_only on the 24 history questions: llama2 +0.32, codellama +0.28, both with intervals excluding 0, so history is useful for them. starcoder2:3b shows no effect. Honest reading: automatic scoring, small samples, one repository.</a:t>
+              <a:t>Show Grafana at localhost:3000 (dashboard CodeOrigin overview). Top: live service metrics from the gateway (requests per second, p95 latency, guardrail triggers, LLM tokens) and logs from Loki. Middle: the evaluation results of the selected run exported as metrics by the eval service. Bottom: quality and cost per model: hallucination rate, retrieval recall and precision by mode, latency, tokens. Pick the run in the Eval run selector. Ask a question on the Ask page first so the live panels move.</a:t>
             </a:r>
             <a:endParaRPr lang="en-US" dirty="0"/>
           </a:p>
@@ -2897,7 +2986,7 @@
                   <a:srgbClr val="0071E3"/>
                 </a:solidFill>
               </a:rPr>
-              <a:t>RESULTS AND INTERPRETATION</a:t>
+              <a:t>RESULTS: HELD-OUT RUN ON A REAL REPOSITORY</a:t>
             </a:r>
             <a:endParaRPr lang="en-US" sz="1200" dirty="0"/>
           </a:p>
@@ -2933,15 +3022,761 @@
                   <a:srgbClr val="1D1D1F"/>
                 </a:solidFill>
               </a:rPr>
-              <a:t>What the numbers mean</a:t>
+              <a:t>What the experiment shows</a:t>
             </a:r>
             <a:endParaRPr lang="en-US" sz="3600" dirty="0"/>
+          </a:p>
+        </p:txBody>
+      </p:sp>
+      <p:sp>
+        <p:nvSpPr>
+          <p:cNvPr id="4" name="Text 2"/>
+          <p:cNvSpPr txBox="1"/>
+          <p:nvPr/>
+        </p:nvSpPr>
+        <p:spPr>
+          <a:xfrm>
+            <a:off x="548640" y="1371600"/>
+            <a:ext cx="11091672" cy="548640"/>
+          </a:xfrm>
+          <a:prstGeom prst="rect">
+            <a:avLst/>
+          </a:prstGeom>
+          <a:noFill/>
+          <a:ln/>
+        </p:spPr>
+        <p:txBody>
+          <a:bodyPr wrap="square" lIns="0" tIns="0" rIns="0" bIns="0" rtlCol="0" anchor="t"/>
+          <a:lstStyle/>
+          <a:p>
+            <a:pPr indent="0" marL="0">
+              <a:buNone/>
+            </a:pPr>
+            <a:r>
+              <a:rPr lang="en-US" sz="1600" dirty="0">
+                <a:solidFill>
+                  <a:srgbClr val="55555B"/>
+                </a:solidFill>
+              </a:rPr>
+              <a:t>Run #8: pallets/itsdangerous, 35 questions, 399 answers, real local models. Overall correctness per mode.</a:t>
+            </a:r>
+            <a:endParaRPr lang="en-US" sz="1600" dirty="0"/>
           </a:p>
         </p:txBody>
       </p:sp>
       <p:graphicFrame>
         <p:nvGraphicFramePr>
-          <p:cNvPr id="11" name="Table 0"/>
+          <p:cNvPr id="6" name="Chart 0" descr=""/>
+          <p:cNvGraphicFramePr/>
+          <p:nvPr/>
+        </p:nvGraphicFramePr>
+        <p:xfrm>
+          <a:off x="548640" y="2011680"/>
+          <a:ext cx="6949440" cy="4206240"/>
+        </p:xfrm>
+        <a:graphic xmlns:a="http://schemas.openxmlformats.org/drawingml/2006/main">
+          <a:graphicData uri="http://schemas.openxmlformats.org/drawingml/2006/chart">
+            <c:chart xmlns:c="http://schemas.openxmlformats.org/drawingml/2006/chart" r:id="rId1"/>
+          </a:graphicData>
+        </a:graphic>
+      </p:graphicFrame>
+      <p:sp>
+        <p:nvSpPr>
+          <p:cNvPr id="7" name="Text 3"/>
+          <p:cNvSpPr txBox="1"/>
+          <p:nvPr/>
+        </p:nvSpPr>
+        <p:spPr>
+          <a:xfrm>
+            <a:off x="7772400" y="2011680"/>
+            <a:ext cx="3840480" cy="320040"/>
+          </a:xfrm>
+          <a:prstGeom prst="rect">
+            <a:avLst/>
+          </a:prstGeom>
+          <a:noFill/>
+          <a:ln/>
+        </p:spPr>
+        <p:txBody>
+          <a:bodyPr wrap="square" lIns="0" tIns="0" rIns="0" bIns="0" rtlCol="0" anchor="ctr"/>
+          <a:lstStyle/>
+          <a:p>
+            <a:pPr indent="0" marL="0">
+              <a:buNone/>
+            </a:pPr>
+            <a:r>
+              <a:rPr lang="en-US" sz="1400" b="1" dirty="0">
+                <a:solidFill>
+                  <a:srgbClr val="1D1D1F"/>
+                </a:solidFill>
+              </a:rPr>
+              <a:t>History vs code-only (24 history questions)</a:t>
+            </a:r>
+            <a:endParaRPr lang="en-US" sz="1400" dirty="0"/>
+          </a:p>
+        </p:txBody>
+      </p:sp>
+      <p:sp>
+        <p:nvSpPr>
+          <p:cNvPr id="8" name="Shape 4"/>
+          <p:cNvSpPr/>
+          <p:nvPr/>
+        </p:nvSpPr>
+        <p:spPr>
+          <a:xfrm>
+            <a:off x="7772400" y="2423160"/>
+            <a:ext cx="3867912" cy="1051560"/>
+          </a:xfrm>
+          <a:prstGeom prst="roundRect">
+            <a:avLst>
+              <a:gd name="adj" fmla="val 8696"/>
+            </a:avLst>
+          </a:prstGeom>
+          <a:solidFill>
+            <a:srgbClr val="FFFFFF"/>
+          </a:solidFill>
+          <a:ln w="9525">
+            <a:solidFill>
+              <a:srgbClr val="D9D9DE"/>
+            </a:solidFill>
+            <a:prstDash val="solid"/>
+          </a:ln>
+        </p:spPr>
+      </p:sp>
+      <p:sp>
+        <p:nvSpPr>
+          <p:cNvPr id="9" name="Text 5"/>
+          <p:cNvSpPr txBox="1"/>
+          <p:nvPr/>
+        </p:nvSpPr>
+        <p:spPr>
+          <a:xfrm>
+            <a:off x="7955280" y="2514600"/>
+            <a:ext cx="2011680" cy="320040"/>
+          </a:xfrm>
+          <a:prstGeom prst="rect">
+            <a:avLst/>
+          </a:prstGeom>
+          <a:noFill/>
+          <a:ln/>
+        </p:spPr>
+        <p:txBody>
+          <a:bodyPr wrap="square" lIns="0" tIns="0" rIns="0" bIns="0" rtlCol="0" anchor="ctr"/>
+          <a:lstStyle/>
+          <a:p>
+            <a:pPr indent="0" marL="0">
+              <a:buNone/>
+            </a:pPr>
+            <a:r>
+              <a:rPr lang="en-US" sz="1500" b="1" dirty="0">
+                <a:solidFill>
+                  <a:srgbClr val="1D1D1F"/>
+                </a:solidFill>
+              </a:rPr>
+              <a:t>llama2</a:t>
+            </a:r>
+            <a:endParaRPr lang="en-US" sz="1500" dirty="0"/>
+          </a:p>
+        </p:txBody>
+      </p:sp>
+      <p:sp>
+        <p:nvSpPr>
+          <p:cNvPr id="10" name="Text 6"/>
+          <p:cNvSpPr txBox="1"/>
+          <p:nvPr/>
+        </p:nvSpPr>
+        <p:spPr>
+          <a:xfrm>
+            <a:off x="9966960" y="2468880"/>
+            <a:ext cx="1554480" cy="457200"/>
+          </a:xfrm>
+          <a:prstGeom prst="rect">
+            <a:avLst/>
+          </a:prstGeom>
+          <a:noFill/>
+          <a:ln/>
+        </p:spPr>
+        <p:txBody>
+          <a:bodyPr wrap="square" lIns="0" tIns="0" rIns="0" bIns="0" rtlCol="0" anchor="ctr"/>
+          <a:lstStyle/>
+          <a:p>
+            <a:pPr algn="r" indent="0" marL="0">
+              <a:buNone/>
+            </a:pPr>
+            <a:r>
+              <a:rPr lang="en-US" sz="2400" b="1" dirty="0">
+                <a:solidFill>
+                  <a:srgbClr val="1E9E6A"/>
+                </a:solidFill>
+              </a:rPr>
+              <a:t>+0.32</a:t>
+            </a:r>
+            <a:endParaRPr lang="en-US" sz="2400" dirty="0"/>
+          </a:p>
+        </p:txBody>
+      </p:sp>
+      <p:sp>
+        <p:nvSpPr>
+          <p:cNvPr id="11" name="Text 7"/>
+          <p:cNvSpPr txBox="1"/>
+          <p:nvPr/>
+        </p:nvSpPr>
+        <p:spPr>
+          <a:xfrm>
+            <a:off x="7955280" y="2880360"/>
+            <a:ext cx="3566160" cy="274320"/>
+          </a:xfrm>
+          <a:prstGeom prst="rect">
+            <a:avLst/>
+          </a:prstGeom>
+          <a:noFill/>
+          <a:ln/>
+        </p:spPr>
+        <p:txBody>
+          <a:bodyPr wrap="square" lIns="0" tIns="0" rIns="0" bIns="0" rtlCol="0" anchor="ctr"/>
+          <a:lstStyle/>
+          <a:p>
+            <a:pPr indent="0" marL="0">
+              <a:buNone/>
+            </a:pPr>
+            <a:r>
+              <a:rPr lang="en-US" sz="1200" dirty="0">
+                <a:solidFill>
+                  <a:srgbClr val="55555B"/>
+                </a:solidFill>
+              </a:rPr>
+              <a:t>95% CI [+0.07, +0.55]</a:t>
+            </a:r>
+            <a:endParaRPr lang="en-US" sz="1200" dirty="0"/>
+          </a:p>
+        </p:txBody>
+      </p:sp>
+      <p:sp>
+        <p:nvSpPr>
+          <p:cNvPr id="12" name="Text 8"/>
+          <p:cNvSpPr txBox="1"/>
+          <p:nvPr/>
+        </p:nvSpPr>
+        <p:spPr>
+          <a:xfrm>
+            <a:off x="7955280" y="3136392"/>
+            <a:ext cx="3566160" cy="274320"/>
+          </a:xfrm>
+          <a:prstGeom prst="rect">
+            <a:avLst/>
+          </a:prstGeom>
+          <a:noFill/>
+          <a:ln/>
+        </p:spPr>
+        <p:txBody>
+          <a:bodyPr wrap="square" lIns="0" tIns="0" rIns="0" bIns="0" rtlCol="0" anchor="ctr"/>
+          <a:lstStyle/>
+          <a:p>
+            <a:pPr indent="0" marL="0">
+              <a:buNone/>
+            </a:pPr>
+            <a:r>
+              <a:rPr lang="en-US" sz="1300" b="1" dirty="0">
+                <a:solidFill>
+                  <a:srgbClr val="1E9E6A"/>
+                </a:solidFill>
+              </a:rPr>
+              <a:t>history is useful</a:t>
+            </a:r>
+            <a:endParaRPr lang="en-US" sz="1300" dirty="0"/>
+          </a:p>
+        </p:txBody>
+      </p:sp>
+      <p:sp>
+        <p:nvSpPr>
+          <p:cNvPr id="13" name="Shape 9"/>
+          <p:cNvSpPr/>
+          <p:nvPr/>
+        </p:nvSpPr>
+        <p:spPr>
+          <a:xfrm>
+            <a:off x="7772400" y="3611880"/>
+            <a:ext cx="3867912" cy="1051560"/>
+          </a:xfrm>
+          <a:prstGeom prst="roundRect">
+            <a:avLst>
+              <a:gd name="adj" fmla="val 8696"/>
+            </a:avLst>
+          </a:prstGeom>
+          <a:solidFill>
+            <a:srgbClr val="FFFFFF"/>
+          </a:solidFill>
+          <a:ln w="9525">
+            <a:solidFill>
+              <a:srgbClr val="D9D9DE"/>
+            </a:solidFill>
+            <a:prstDash val="solid"/>
+          </a:ln>
+        </p:spPr>
+      </p:sp>
+      <p:sp>
+        <p:nvSpPr>
+          <p:cNvPr id="14" name="Text 10"/>
+          <p:cNvSpPr txBox="1"/>
+          <p:nvPr/>
+        </p:nvSpPr>
+        <p:spPr>
+          <a:xfrm>
+            <a:off x="7955280" y="3703320"/>
+            <a:ext cx="2011680" cy="320040"/>
+          </a:xfrm>
+          <a:prstGeom prst="rect">
+            <a:avLst/>
+          </a:prstGeom>
+          <a:noFill/>
+          <a:ln/>
+        </p:spPr>
+        <p:txBody>
+          <a:bodyPr wrap="square" lIns="0" tIns="0" rIns="0" bIns="0" rtlCol="0" anchor="ctr"/>
+          <a:lstStyle/>
+          <a:p>
+            <a:pPr indent="0" marL="0">
+              <a:buNone/>
+            </a:pPr>
+            <a:r>
+              <a:rPr lang="en-US" sz="1500" b="1" dirty="0">
+                <a:solidFill>
+                  <a:srgbClr val="1D1D1F"/>
+                </a:solidFill>
+              </a:rPr>
+              <a:t>codellama:7b</a:t>
+            </a:r>
+            <a:endParaRPr lang="en-US" sz="1500" dirty="0"/>
+          </a:p>
+        </p:txBody>
+      </p:sp>
+      <p:sp>
+        <p:nvSpPr>
+          <p:cNvPr id="15" name="Text 11"/>
+          <p:cNvSpPr txBox="1"/>
+          <p:nvPr/>
+        </p:nvSpPr>
+        <p:spPr>
+          <a:xfrm>
+            <a:off x="9966960" y="3657600"/>
+            <a:ext cx="1554480" cy="457200"/>
+          </a:xfrm>
+          <a:prstGeom prst="rect">
+            <a:avLst/>
+          </a:prstGeom>
+          <a:noFill/>
+          <a:ln/>
+        </p:spPr>
+        <p:txBody>
+          <a:bodyPr wrap="square" lIns="0" tIns="0" rIns="0" bIns="0" rtlCol="0" anchor="ctr"/>
+          <a:lstStyle/>
+          <a:p>
+            <a:pPr algn="r" indent="0" marL="0">
+              <a:buNone/>
+            </a:pPr>
+            <a:r>
+              <a:rPr lang="en-US" sz="2400" b="1" dirty="0">
+                <a:solidFill>
+                  <a:srgbClr val="1E9E6A"/>
+                </a:solidFill>
+              </a:rPr>
+              <a:t>+0.28</a:t>
+            </a:r>
+            <a:endParaRPr lang="en-US" sz="2400" dirty="0"/>
+          </a:p>
+        </p:txBody>
+      </p:sp>
+      <p:sp>
+        <p:nvSpPr>
+          <p:cNvPr id="16" name="Text 12"/>
+          <p:cNvSpPr txBox="1"/>
+          <p:nvPr/>
+        </p:nvSpPr>
+        <p:spPr>
+          <a:xfrm>
+            <a:off x="7955280" y="4069080"/>
+            <a:ext cx="3566160" cy="274320"/>
+          </a:xfrm>
+          <a:prstGeom prst="rect">
+            <a:avLst/>
+          </a:prstGeom>
+          <a:noFill/>
+          <a:ln/>
+        </p:spPr>
+        <p:txBody>
+          <a:bodyPr wrap="square" lIns="0" tIns="0" rIns="0" bIns="0" rtlCol="0" anchor="ctr"/>
+          <a:lstStyle/>
+          <a:p>
+            <a:pPr indent="0" marL="0">
+              <a:buNone/>
+            </a:pPr>
+            <a:r>
+              <a:rPr lang="en-US" sz="1200" dirty="0">
+                <a:solidFill>
+                  <a:srgbClr val="55555B"/>
+                </a:solidFill>
+              </a:rPr>
+              <a:t>95% CI [+0.05, +0.49]</a:t>
+            </a:r>
+            <a:endParaRPr lang="en-US" sz="1200" dirty="0"/>
+          </a:p>
+        </p:txBody>
+      </p:sp>
+      <p:sp>
+        <p:nvSpPr>
+          <p:cNvPr id="17" name="Text 13"/>
+          <p:cNvSpPr txBox="1"/>
+          <p:nvPr/>
+        </p:nvSpPr>
+        <p:spPr>
+          <a:xfrm>
+            <a:off x="7955280" y="4325112"/>
+            <a:ext cx="3566160" cy="274320"/>
+          </a:xfrm>
+          <a:prstGeom prst="rect">
+            <a:avLst/>
+          </a:prstGeom>
+          <a:noFill/>
+          <a:ln/>
+        </p:spPr>
+        <p:txBody>
+          <a:bodyPr wrap="square" lIns="0" tIns="0" rIns="0" bIns="0" rtlCol="0" anchor="ctr"/>
+          <a:lstStyle/>
+          <a:p>
+            <a:pPr indent="0" marL="0">
+              <a:buNone/>
+            </a:pPr>
+            <a:r>
+              <a:rPr lang="en-US" sz="1300" b="1" dirty="0">
+                <a:solidFill>
+                  <a:srgbClr val="1E9E6A"/>
+                </a:solidFill>
+              </a:rPr>
+              <a:t>history is useful</a:t>
+            </a:r>
+            <a:endParaRPr lang="en-US" sz="1300" dirty="0"/>
+          </a:p>
+        </p:txBody>
+      </p:sp>
+      <p:sp>
+        <p:nvSpPr>
+          <p:cNvPr id="18" name="Shape 14"/>
+          <p:cNvSpPr/>
+          <p:nvPr/>
+        </p:nvSpPr>
+        <p:spPr>
+          <a:xfrm>
+            <a:off x="7772400" y="4800600"/>
+            <a:ext cx="3867912" cy="1051560"/>
+          </a:xfrm>
+          <a:prstGeom prst="roundRect">
+            <a:avLst>
+              <a:gd name="adj" fmla="val 8696"/>
+            </a:avLst>
+          </a:prstGeom>
+          <a:solidFill>
+            <a:srgbClr val="FFFFFF"/>
+          </a:solidFill>
+          <a:ln w="9525">
+            <a:solidFill>
+              <a:srgbClr val="D9D9DE"/>
+            </a:solidFill>
+            <a:prstDash val="solid"/>
+          </a:ln>
+        </p:spPr>
+      </p:sp>
+      <p:sp>
+        <p:nvSpPr>
+          <p:cNvPr id="19" name="Text 15"/>
+          <p:cNvSpPr txBox="1"/>
+          <p:nvPr/>
+        </p:nvSpPr>
+        <p:spPr>
+          <a:xfrm>
+            <a:off x="7955280" y="4892040"/>
+            <a:ext cx="2011680" cy="320040"/>
+          </a:xfrm>
+          <a:prstGeom prst="rect">
+            <a:avLst/>
+          </a:prstGeom>
+          <a:noFill/>
+          <a:ln/>
+        </p:spPr>
+        <p:txBody>
+          <a:bodyPr wrap="square" lIns="0" tIns="0" rIns="0" bIns="0" rtlCol="0" anchor="ctr"/>
+          <a:lstStyle/>
+          <a:p>
+            <a:pPr indent="0" marL="0">
+              <a:buNone/>
+            </a:pPr>
+            <a:r>
+              <a:rPr lang="en-US" sz="1500" b="1" dirty="0">
+                <a:solidFill>
+                  <a:srgbClr val="1D1D1F"/>
+                </a:solidFill>
+              </a:rPr>
+              <a:t>starcoder2:3b</a:t>
+            </a:r>
+            <a:endParaRPr lang="en-US" sz="1500" dirty="0"/>
+          </a:p>
+        </p:txBody>
+      </p:sp>
+      <p:sp>
+        <p:nvSpPr>
+          <p:cNvPr id="20" name="Text 16"/>
+          <p:cNvSpPr txBox="1"/>
+          <p:nvPr/>
+        </p:nvSpPr>
+        <p:spPr>
+          <a:xfrm>
+            <a:off x="9966960" y="4846320"/>
+            <a:ext cx="1554480" cy="457200"/>
+          </a:xfrm>
+          <a:prstGeom prst="rect">
+            <a:avLst/>
+          </a:prstGeom>
+          <a:noFill/>
+          <a:ln/>
+        </p:spPr>
+        <p:txBody>
+          <a:bodyPr wrap="square" lIns="0" tIns="0" rIns="0" bIns="0" rtlCol="0" anchor="ctr"/>
+          <a:lstStyle/>
+          <a:p>
+            <a:pPr algn="r" indent="0" marL="0">
+              <a:buNone/>
+            </a:pPr>
+            <a:r>
+              <a:rPr lang="en-US" sz="2400" b="1" dirty="0">
+                <a:solidFill>
+                  <a:srgbClr val="55555B"/>
+                </a:solidFill>
+              </a:rPr>
+              <a:t>−0.02</a:t>
+            </a:r>
+            <a:endParaRPr lang="en-US" sz="2400" dirty="0"/>
+          </a:p>
+        </p:txBody>
+      </p:sp>
+      <p:sp>
+        <p:nvSpPr>
+          <p:cNvPr id="21" name="Text 17"/>
+          <p:cNvSpPr txBox="1"/>
+          <p:nvPr/>
+        </p:nvSpPr>
+        <p:spPr>
+          <a:xfrm>
+            <a:off x="7955280" y="5257800"/>
+            <a:ext cx="3566160" cy="274320"/>
+          </a:xfrm>
+          <a:prstGeom prst="rect">
+            <a:avLst/>
+          </a:prstGeom>
+          <a:noFill/>
+          <a:ln/>
+        </p:spPr>
+        <p:txBody>
+          <a:bodyPr wrap="square" lIns="0" tIns="0" rIns="0" bIns="0" rtlCol="0" anchor="ctr"/>
+          <a:lstStyle/>
+          <a:p>
+            <a:pPr indent="0" marL="0">
+              <a:buNone/>
+            </a:pPr>
+            <a:r>
+              <a:rPr lang="en-US" sz="1200" dirty="0">
+                <a:solidFill>
+                  <a:srgbClr val="55555B"/>
+                </a:solidFill>
+              </a:rPr>
+              <a:t>95% CI [−0.21, +0.17]</a:t>
+            </a:r>
+            <a:endParaRPr lang="en-US" sz="1200" dirty="0"/>
+          </a:p>
+        </p:txBody>
+      </p:sp>
+      <p:sp>
+        <p:nvSpPr>
+          <p:cNvPr id="22" name="Text 18"/>
+          <p:cNvSpPr txBox="1"/>
+          <p:nvPr/>
+        </p:nvSpPr>
+        <p:spPr>
+          <a:xfrm>
+            <a:off x="7955280" y="5513832"/>
+            <a:ext cx="3566160" cy="274320"/>
+          </a:xfrm>
+          <a:prstGeom prst="rect">
+            <a:avLst/>
+          </a:prstGeom>
+          <a:noFill/>
+          <a:ln/>
+        </p:spPr>
+        <p:txBody>
+          <a:bodyPr wrap="square" lIns="0" tIns="0" rIns="0" bIns="0" rtlCol="0" anchor="ctr"/>
+          <a:lstStyle/>
+          <a:p>
+            <a:pPr indent="0" marL="0">
+              <a:buNone/>
+            </a:pPr>
+            <a:r>
+              <a:rPr lang="en-US" sz="1300" b="1" dirty="0">
+                <a:solidFill>
+                  <a:srgbClr val="55555B"/>
+                </a:solidFill>
+              </a:rPr>
+              <a:t>no effect detected</a:t>
+            </a:r>
+            <a:endParaRPr lang="en-US" sz="1300" dirty="0"/>
+          </a:p>
+        </p:txBody>
+      </p:sp>
+      <p:sp>
+        <p:nvSpPr>
+          <p:cNvPr id="25" name="Slide Number Placeholder 0"/>
+          <p:cNvSpPr>
+            <a:spLocks noGrp="1"/>
+          </p:cNvSpPr>
+          <p:nvPr>
+            <p:ph type="sldNum" sz="quarter" idx="4294967295"/>
+          </p:nvPr>
+        </p:nvSpPr>
+        <p:spPr>
+          <a:xfrm>
+            <a:off x="10725912" y="6419088"/>
+            <a:ext cx="914400" cy="274320"/>
+          </a:xfrm>
+          <a:prstGeom prst="rect">
+            <a:avLst/>
+          </a:prstGeom>
+          <a:extLst>
+            <a:ext uri="{C572A759-6A51-4108-AA02-DFA0A04FC94B}">
+              <ma14:wrappingTextBoxFlag xmlns:ma14="http://schemas.microsoft.com/office/mac/drawingml/2011/main" val="0"/>
+            </a:ext>
+          </a:extLst>
+        </p:spPr>
+        <p:txBody>
+          <a:bodyPr/>
+          <a:lstStyle>
+            <a:lvl1pPr>
+              <a:defRPr sz="1100">
+                <a:solidFill>
+                  <a:srgbClr val="55555B"/>
+                </a:solidFill>
+                <a:latin typeface="Calibri"/>
+                <a:ea typeface="Calibri"/>
+                <a:cs typeface="Calibri"/>
+              </a:defRPr>
+            </a:lvl1pPr>
+          </a:lstStyle>
+          <a:p>
+            <a:pPr algn="r"/>
+            <a:fld id="{F7021451-1387-4CA6-816F-3879F97B5CBC}" type="slidenum">
+              <a:rPr b="0" lang="en-US"/>
+              <a:t>10</a:t>
+            </a:fld>
+            <a:endParaRPr lang="en-US"/>
+          </a:p>
+        </p:txBody>
+      </p:sp>
+    </p:spTree>
+  </p:cSld>
+  <p:clrMapOvr>
+    <a:masterClrMapping/>
+  </p:clrMapOvr>
+</p:sld>
+</file>
+
+<file path=ppt/slides/slide11.xml><?xml version="1.0" encoding="utf-8"?>
+<p:sld xmlns:a="http://schemas.openxmlformats.org/drawingml/2006/main" xmlns:r="http://schemas.openxmlformats.org/officeDocument/2006/relationships" xmlns:p="http://schemas.openxmlformats.org/presentationml/2006/main">
+  <p:cSld name="Slide 11">
+    <p:spTree>
+      <p:nvGrpSpPr>
+        <p:cNvPr id="1" name=""/>
+        <p:cNvGrpSpPr/>
+        <p:nvPr/>
+      </p:nvGrpSpPr>
+      <p:grpSpPr>
+        <a:xfrm>
+          <a:off x="0" y="0"/>
+          <a:ext cx="0" cy="0"/>
+          <a:chOff x="0" y="0"/>
+          <a:chExt cx="0" cy="0"/>
+        </a:xfrm>
+      </p:grpSpPr>
+      <p:sp>
+        <p:nvSpPr>
+          <p:cNvPr id="2" name="Text 0"/>
+          <p:cNvSpPr txBox="1"/>
+          <p:nvPr/>
+        </p:nvSpPr>
+        <p:spPr>
+          <a:xfrm>
+            <a:off x="548640" y="365760"/>
+            <a:ext cx="11091672" cy="274320"/>
+          </a:xfrm>
+          <a:prstGeom prst="rect">
+            <a:avLst/>
+          </a:prstGeom>
+          <a:noFill/>
+          <a:ln/>
+        </p:spPr>
+        <p:txBody>
+          <a:bodyPr wrap="square" lIns="0" tIns="0" rIns="0" bIns="0" rtlCol="0" anchor="ctr"/>
+          <a:lstStyle/>
+          <a:p>
+            <a:pPr indent="0" marL="0">
+              <a:buNone/>
+            </a:pPr>
+            <a:r>
+              <a:rPr lang="en-US" sz="1200" b="1" spc="200" kern="0" dirty="0">
+                <a:solidFill>
+                  <a:srgbClr val="0071E3"/>
+                </a:solidFill>
+              </a:rPr>
+              <a:t>RESULTS AND INTERPRETATION</a:t>
+            </a:r>
+            <a:endParaRPr lang="en-US" sz="1200" dirty="0"/>
+          </a:p>
+        </p:txBody>
+      </p:sp>
+      <p:sp>
+        <p:nvSpPr>
+          <p:cNvPr id="3" name="Text 1"/>
+          <p:cNvSpPr txBox="1"/>
+          <p:nvPr/>
+        </p:nvSpPr>
+        <p:spPr>
+          <a:xfrm>
+            <a:off x="548640" y="658368"/>
+            <a:ext cx="11091672" cy="731520"/>
+          </a:xfrm>
+          <a:prstGeom prst="rect">
+            <a:avLst/>
+          </a:prstGeom>
+          <a:noFill/>
+          <a:ln/>
+        </p:spPr>
+        <p:txBody>
+          <a:bodyPr wrap="square" lIns="0" tIns="0" rIns="0" bIns="0" rtlCol="0" anchor="ctr"/>
+          <a:lstStyle/>
+          <a:p>
+            <a:pPr indent="0" marL="0">
+              <a:buNone/>
+            </a:pPr>
+            <a:r>
+              <a:rPr lang="en-US" sz="3600" b="1" dirty="0">
+                <a:solidFill>
+                  <a:srgbClr val="1D1D1F"/>
+                </a:solidFill>
+              </a:rPr>
+              <a:t>What the numbers mean</a:t>
+            </a:r>
+            <a:endParaRPr lang="en-US" sz="3600" dirty="0"/>
+          </a:p>
+        </p:txBody>
+      </p:sp>
+      <p:graphicFrame>
+        <p:nvGraphicFramePr>
+          <p:cNvPr id="12" name="Table 0"/>
           <p:cNvGraphicFramePr>
             <a:graphicFrameLocks noGrp="1"/>
           </p:cNvGraphicFramePr>
@@ -6617,7 +7452,7 @@
             <a:pPr algn="r"/>
             <a:fld id="{F7021451-1387-4CA6-816F-3879F97B5CBC}" type="slidenum">
               <a:rPr b="0" lang="en-US"/>
-              <a:t>10</a:t>
+              <a:t>11</a:t>
             </a:fld>
             <a:endParaRPr lang="en-US"/>
           </a:p>
@@ -6631,9 +7466,9 @@
 </p:sld>
 </file>
 
-<file path=ppt/slides/slide11.xml><?xml version="1.0" encoding="utf-8"?>
+<file path=ppt/slides/slide12.xml><?xml version="1.0" encoding="utf-8"?>
 <p:sld xmlns:a="http://schemas.openxmlformats.org/drawingml/2006/main" xmlns:r="http://schemas.openxmlformats.org/officeDocument/2006/relationships" xmlns:p="http://schemas.openxmlformats.org/presentationml/2006/main">
-  <p:cSld name="Slide 11">
+  <p:cSld name="Slide 12">
     <p:spTree>
       <p:nvGrpSpPr>
         <p:cNvPr id="1" name=""/>
@@ -6722,7 +7557,7 @@
       </p:sp>
       <p:graphicFrame>
         <p:nvGraphicFramePr>
-          <p:cNvPr id="12" name="Table 0"/>
+          <p:cNvPr id="13" name="Table 0"/>
           <p:cNvGraphicFramePr>
             <a:graphicFrameLocks noGrp="1"/>
           </p:cNvGraphicFramePr>
@@ -10134,7 +10969,7 @@
                   <a:srgbClr val="55555B"/>
                 </a:solidFill>
               </a:rPr>
-              <a:t>Hallucination rate: llama2 29%, codellama 20%, starcoder2 54%. Median latency: 8.3 s, 16.1 s, 1.4 s. Tokens out: 90, 193, 44.</a:t>
+              <a:t>Hallucination rate: llama2 31%, codellama 22%, starcoder2 59%. Median latency: 8.3 s, 16.1 s, 1.4 s (means 12.0, 14.5, 2.3). Tokens out (median): 90, 193, 44. Live in Grafana.</a:t>
             </a:r>
             <a:endParaRPr lang="en-US" sz="1300" dirty="0"/>
           </a:p>
@@ -10288,7 +11123,7 @@
             <a:pPr algn="r"/>
             <a:fld id="{F7021451-1387-4CA6-816F-3879F97B5CBC}" type="slidenum">
               <a:rPr b="0" lang="en-US"/>
-              <a:t>11</a:t>
+              <a:t>12</a:t>
             </a:fld>
             <a:endParaRPr lang="en-US"/>
           </a:p>
@@ -10302,9 +11137,9 @@
 </p:sld>
 </file>
 
-<file path=ppt/slides/slide12.xml><?xml version="1.0" encoding="utf-8"?>
+<file path=ppt/slides/slide13.xml><?xml version="1.0" encoding="utf-8"?>
 <p:sld xmlns:a="http://schemas.openxmlformats.org/drawingml/2006/main" xmlns:r="http://schemas.openxmlformats.org/officeDocument/2006/relationships" xmlns:p="http://schemas.openxmlformats.org/presentationml/2006/main">
-  <p:cSld name="Slide 12">
+  <p:cSld name="Slide 13">
     <p:spTree>
       <p:nvGrpSpPr>
         <p:cNvPr id="1" name=""/>
@@ -10393,7 +11228,7 @@
       </p:sp>
       <p:graphicFrame>
         <p:nvGraphicFramePr>
-          <p:cNvPr id="13" name="Table 0"/>
+          <p:cNvPr id="14" name="Table 0"/>
           <p:cNvGraphicFramePr>
             <a:graphicFrameLocks noGrp="1"/>
           </p:cNvGraphicFramePr>
@@ -11906,1065 +12741,6 @@
             <a:pPr algn="r"/>
             <a:fld id="{F7021451-1387-4CA6-816F-3879F97B5CBC}" type="slidenum">
               <a:rPr b="0" lang="en-US"/>
-              <a:t>12</a:t>
-            </a:fld>
-            <a:endParaRPr lang="en-US"/>
-          </a:p>
-        </p:txBody>
-      </p:sp>
-    </p:spTree>
-  </p:cSld>
-  <p:clrMapOvr>
-    <a:masterClrMapping/>
-  </p:clrMapOvr>
-</p:sld>
-</file>
-
-<file path=ppt/slides/slide13.xml><?xml version="1.0" encoding="utf-8"?>
-<p:sld xmlns:a="http://schemas.openxmlformats.org/drawingml/2006/main" xmlns:r="http://schemas.openxmlformats.org/officeDocument/2006/relationships" xmlns:p="http://schemas.openxmlformats.org/presentationml/2006/main">
-  <p:cSld name="Slide 13">
-    <p:spTree>
-      <p:nvGrpSpPr>
-        <p:cNvPr id="1" name=""/>
-        <p:cNvGrpSpPr/>
-        <p:nvPr/>
-      </p:nvGrpSpPr>
-      <p:grpSpPr>
-        <a:xfrm>
-          <a:off x="0" y="0"/>
-          <a:ext cx="0" cy="0"/>
-          <a:chOff x="0" y="0"/>
-          <a:chExt cx="0" cy="0"/>
-        </a:xfrm>
-      </p:grpSpPr>
-      <p:sp>
-        <p:nvSpPr>
-          <p:cNvPr id="2" name="Text 0"/>
-          <p:cNvSpPr txBox="1"/>
-          <p:nvPr/>
-        </p:nvSpPr>
-        <p:spPr>
-          <a:xfrm>
-            <a:off x="548640" y="365760"/>
-            <a:ext cx="11091672" cy="274320"/>
-          </a:xfrm>
-          <a:prstGeom prst="rect">
-            <a:avLst/>
-          </a:prstGeom>
-          <a:noFill/>
-          <a:ln/>
-        </p:spPr>
-        <p:txBody>
-          <a:bodyPr wrap="square" lIns="0" tIns="0" rIns="0" bIns="0" rtlCol="0" anchor="ctr"/>
-          <a:lstStyle/>
-          <a:p>
-            <a:pPr indent="0" marL="0">
-              <a:buNone/>
-            </a:pPr>
-            <a:r>
-              <a:rPr lang="en-US" sz="1200" b="1" spc="200" kern="0" dirty="0">
-                <a:solidFill>
-                  <a:srgbClr val="0071E3"/>
-                </a:solidFill>
-              </a:rPr>
-              <a:t>LIVE SYSTEM</a:t>
-            </a:r>
-            <a:endParaRPr lang="en-US" sz="1200" dirty="0"/>
-          </a:p>
-        </p:txBody>
-      </p:sp>
-      <p:sp>
-        <p:nvSpPr>
-          <p:cNvPr id="3" name="Text 1"/>
-          <p:cNvSpPr txBox="1"/>
-          <p:nvPr/>
-        </p:nvSpPr>
-        <p:spPr>
-          <a:xfrm>
-            <a:off x="548640" y="658368"/>
-            <a:ext cx="11091672" cy="731520"/>
-          </a:xfrm>
-          <a:prstGeom prst="rect">
-            <a:avLst/>
-          </a:prstGeom>
-          <a:noFill/>
-          <a:ln/>
-        </p:spPr>
-        <p:txBody>
-          <a:bodyPr wrap="square" lIns="0" tIns="0" rIns="0" bIns="0" rtlCol="0" anchor="ctr"/>
-          <a:lstStyle/>
-          <a:p>
-            <a:pPr indent="0" marL="0">
-              <a:buNone/>
-            </a:pPr>
-            <a:r>
-              <a:rPr lang="en-US" sz="3600" b="1" dirty="0">
-                <a:solidFill>
-                  <a:srgbClr val="1D1D1F"/>
-                </a:solidFill>
-              </a:rPr>
-              <a:t>The running stack</a:t>
-            </a:r>
-            <a:endParaRPr lang="en-US" sz="3600" dirty="0"/>
-          </a:p>
-        </p:txBody>
-      </p:sp>
-      <p:sp>
-        <p:nvSpPr>
-          <p:cNvPr id="4" name="Text 2"/>
-          <p:cNvSpPr txBox="1"/>
-          <p:nvPr/>
-        </p:nvSpPr>
-        <p:spPr>
-          <a:xfrm>
-            <a:off x="548640" y="1371600"/>
-            <a:ext cx="11091672" cy="548640"/>
-          </a:xfrm>
-          <a:prstGeom prst="rect">
-            <a:avLst/>
-          </a:prstGeom>
-          <a:noFill/>
-          <a:ln/>
-        </p:spPr>
-        <p:txBody>
-          <a:bodyPr wrap="square" lIns="0" tIns="0" rIns="0" bIns="0" rtlCol="0" anchor="t"/>
-          <a:lstStyle/>
-          <a:p>
-            <a:pPr indent="0" marL="0">
-              <a:buNone/>
-            </a:pPr>
-            <a:r>
-              <a:rPr lang="en-US" sz="1600" dirty="0">
-                <a:solidFill>
-                  <a:srgbClr val="55555B"/>
-                </a:solidFill>
-              </a:rPr>
-              <a:t>Shown live from the website during the talk (health is checked through the gateway every few seconds).</a:t>
-            </a:r>
-            <a:endParaRPr lang="en-US" sz="1600" dirty="0"/>
-          </a:p>
-        </p:txBody>
-      </p:sp>
-      <p:sp>
-        <p:nvSpPr>
-          <p:cNvPr id="6" name="Shape 3"/>
-          <p:cNvSpPr/>
-          <p:nvPr/>
-        </p:nvSpPr>
-        <p:spPr>
-          <a:xfrm>
-            <a:off x="548640" y="2194560"/>
-            <a:ext cx="3514344" cy="731520"/>
-          </a:xfrm>
-          <a:prstGeom prst="roundRect">
-            <a:avLst>
-              <a:gd name="adj" fmla="val 12500"/>
-            </a:avLst>
-          </a:prstGeom>
-          <a:solidFill>
-            <a:srgbClr val="FFFFFF"/>
-          </a:solidFill>
-          <a:ln w="9525">
-            <a:solidFill>
-              <a:srgbClr val="D9D9DE"/>
-            </a:solidFill>
-            <a:prstDash val="solid"/>
-          </a:ln>
-        </p:spPr>
-      </p:sp>
-      <p:sp>
-        <p:nvSpPr>
-          <p:cNvPr id="7" name="Shape 4"/>
-          <p:cNvSpPr/>
-          <p:nvPr/>
-        </p:nvSpPr>
-        <p:spPr>
-          <a:xfrm>
-            <a:off x="777240" y="2441448"/>
-            <a:ext cx="237744" cy="237744"/>
-          </a:xfrm>
-          <a:prstGeom prst="ellipse">
-            <a:avLst/>
-          </a:prstGeom>
-          <a:solidFill>
-            <a:srgbClr val="1E9E6A"/>
-          </a:solidFill>
-          <a:ln w="12700">
-            <a:solidFill>
-              <a:srgbClr val="1E9E6A"/>
-            </a:solidFill>
-            <a:prstDash val="solid"/>
-          </a:ln>
-        </p:spPr>
-      </p:sp>
-      <p:sp>
-        <p:nvSpPr>
-          <p:cNvPr id="8" name="Text 5"/>
-          <p:cNvSpPr txBox="1"/>
-          <p:nvPr/>
-        </p:nvSpPr>
-        <p:spPr>
-          <a:xfrm>
-            <a:off x="1188720" y="2194560"/>
-            <a:ext cx="1685544" cy="731520"/>
-          </a:xfrm>
-          <a:prstGeom prst="rect">
-            <a:avLst/>
-          </a:prstGeom>
-          <a:noFill/>
-          <a:ln/>
-        </p:spPr>
-        <p:txBody>
-          <a:bodyPr wrap="square" lIns="0" tIns="0" rIns="0" bIns="0" rtlCol="0" anchor="ctr"/>
-          <a:lstStyle/>
-          <a:p>
-            <a:pPr indent="0" marL="0">
-              <a:buNone/>
-            </a:pPr>
-            <a:r>
-              <a:rPr lang="en-US" sz="1800" dirty="0">
-                <a:solidFill>
-                  <a:srgbClr val="1D1D1F"/>
-                </a:solidFill>
-              </a:rPr>
-              <a:t>Gateway</a:t>
-            </a:r>
-            <a:endParaRPr lang="en-US" sz="1800" dirty="0"/>
-          </a:p>
-        </p:txBody>
-      </p:sp>
-      <p:sp>
-        <p:nvSpPr>
-          <p:cNvPr id="9" name="Text 6"/>
-          <p:cNvSpPr txBox="1"/>
-          <p:nvPr/>
-        </p:nvSpPr>
-        <p:spPr>
-          <a:xfrm>
-            <a:off x="2874264" y="2194560"/>
-            <a:ext cx="1005840" cy="731520"/>
-          </a:xfrm>
-          <a:prstGeom prst="rect">
-            <a:avLst/>
-          </a:prstGeom>
-          <a:noFill/>
-          <a:ln/>
-        </p:spPr>
-        <p:txBody>
-          <a:bodyPr wrap="square" lIns="0" tIns="0" rIns="0" bIns="0" rtlCol="0" anchor="ctr"/>
-          <a:lstStyle/>
-          <a:p>
-            <a:pPr algn="r" indent="0" marL="0">
-              <a:buNone/>
-            </a:pPr>
-            <a:r>
-              <a:rPr lang="en-US" sz="1300" dirty="0">
-                <a:solidFill>
-                  <a:srgbClr val="55555B"/>
-                </a:solidFill>
-              </a:rPr>
-              <a:t>healthy</a:t>
-            </a:r>
-            <a:endParaRPr lang="en-US" sz="1300" dirty="0"/>
-          </a:p>
-        </p:txBody>
-      </p:sp>
-      <p:sp>
-        <p:nvSpPr>
-          <p:cNvPr id="10" name="Shape 7"/>
-          <p:cNvSpPr/>
-          <p:nvPr/>
-        </p:nvSpPr>
-        <p:spPr>
-          <a:xfrm>
-            <a:off x="4337304" y="2194560"/>
-            <a:ext cx="3514344" cy="731520"/>
-          </a:xfrm>
-          <a:prstGeom prst="roundRect">
-            <a:avLst>
-              <a:gd name="adj" fmla="val 12500"/>
-            </a:avLst>
-          </a:prstGeom>
-          <a:solidFill>
-            <a:srgbClr val="FFFFFF"/>
-          </a:solidFill>
-          <a:ln w="9525">
-            <a:solidFill>
-              <a:srgbClr val="D9D9DE"/>
-            </a:solidFill>
-            <a:prstDash val="solid"/>
-          </a:ln>
-        </p:spPr>
-      </p:sp>
-      <p:sp>
-        <p:nvSpPr>
-          <p:cNvPr id="11" name="Shape 8"/>
-          <p:cNvSpPr/>
-          <p:nvPr/>
-        </p:nvSpPr>
-        <p:spPr>
-          <a:xfrm>
-            <a:off x="4565904" y="2441448"/>
-            <a:ext cx="237744" cy="237744"/>
-          </a:xfrm>
-          <a:prstGeom prst="ellipse">
-            <a:avLst/>
-          </a:prstGeom>
-          <a:solidFill>
-            <a:srgbClr val="1E9E6A"/>
-          </a:solidFill>
-          <a:ln w="12700">
-            <a:solidFill>
-              <a:srgbClr val="1E9E6A"/>
-            </a:solidFill>
-            <a:prstDash val="solid"/>
-          </a:ln>
-        </p:spPr>
-      </p:sp>
-      <p:sp>
-        <p:nvSpPr>
-          <p:cNvPr id="12" name="Text 9"/>
-          <p:cNvSpPr txBox="1"/>
-          <p:nvPr/>
-        </p:nvSpPr>
-        <p:spPr>
-          <a:xfrm>
-            <a:off x="4977384" y="2194560"/>
-            <a:ext cx="1685544" cy="731520"/>
-          </a:xfrm>
-          <a:prstGeom prst="rect">
-            <a:avLst/>
-          </a:prstGeom>
-          <a:noFill/>
-          <a:ln/>
-        </p:spPr>
-        <p:txBody>
-          <a:bodyPr wrap="square" lIns="0" tIns="0" rIns="0" bIns="0" rtlCol="0" anchor="ctr"/>
-          <a:lstStyle/>
-          <a:p>
-            <a:pPr indent="0" marL="0">
-              <a:buNone/>
-            </a:pPr>
-            <a:r>
-              <a:rPr lang="en-US" sz="1800" dirty="0">
-                <a:solidFill>
-                  <a:srgbClr val="1D1D1F"/>
-                </a:solidFill>
-              </a:rPr>
-              <a:t>Ingest</a:t>
-            </a:r>
-            <a:endParaRPr lang="en-US" sz="1800" dirty="0"/>
-          </a:p>
-        </p:txBody>
-      </p:sp>
-      <p:sp>
-        <p:nvSpPr>
-          <p:cNvPr id="13" name="Text 10"/>
-          <p:cNvSpPr txBox="1"/>
-          <p:nvPr/>
-        </p:nvSpPr>
-        <p:spPr>
-          <a:xfrm>
-            <a:off x="6662928" y="2194560"/>
-            <a:ext cx="1005840" cy="731520"/>
-          </a:xfrm>
-          <a:prstGeom prst="rect">
-            <a:avLst/>
-          </a:prstGeom>
-          <a:noFill/>
-          <a:ln/>
-        </p:spPr>
-        <p:txBody>
-          <a:bodyPr wrap="square" lIns="0" tIns="0" rIns="0" bIns="0" rtlCol="0" anchor="ctr"/>
-          <a:lstStyle/>
-          <a:p>
-            <a:pPr algn="r" indent="0" marL="0">
-              <a:buNone/>
-            </a:pPr>
-            <a:r>
-              <a:rPr lang="en-US" sz="1300" dirty="0">
-                <a:solidFill>
-                  <a:srgbClr val="55555B"/>
-                </a:solidFill>
-              </a:rPr>
-              <a:t>healthy</a:t>
-            </a:r>
-            <a:endParaRPr lang="en-US" sz="1300" dirty="0"/>
-          </a:p>
-        </p:txBody>
-      </p:sp>
-      <p:sp>
-        <p:nvSpPr>
-          <p:cNvPr id="14" name="Shape 11"/>
-          <p:cNvSpPr/>
-          <p:nvPr/>
-        </p:nvSpPr>
-        <p:spPr>
-          <a:xfrm>
-            <a:off x="8125968" y="2194560"/>
-            <a:ext cx="3514344" cy="731520"/>
-          </a:xfrm>
-          <a:prstGeom prst="roundRect">
-            <a:avLst>
-              <a:gd name="adj" fmla="val 12500"/>
-            </a:avLst>
-          </a:prstGeom>
-          <a:solidFill>
-            <a:srgbClr val="FFFFFF"/>
-          </a:solidFill>
-          <a:ln w="9525">
-            <a:solidFill>
-              <a:srgbClr val="D9D9DE"/>
-            </a:solidFill>
-            <a:prstDash val="solid"/>
-          </a:ln>
-        </p:spPr>
-      </p:sp>
-      <p:sp>
-        <p:nvSpPr>
-          <p:cNvPr id="15" name="Shape 12"/>
-          <p:cNvSpPr/>
-          <p:nvPr/>
-        </p:nvSpPr>
-        <p:spPr>
-          <a:xfrm>
-            <a:off x="8354568" y="2441448"/>
-            <a:ext cx="237744" cy="237744"/>
-          </a:xfrm>
-          <a:prstGeom prst="ellipse">
-            <a:avLst/>
-          </a:prstGeom>
-          <a:solidFill>
-            <a:srgbClr val="1E9E6A"/>
-          </a:solidFill>
-          <a:ln w="12700">
-            <a:solidFill>
-              <a:srgbClr val="1E9E6A"/>
-            </a:solidFill>
-            <a:prstDash val="solid"/>
-          </a:ln>
-        </p:spPr>
-      </p:sp>
-      <p:sp>
-        <p:nvSpPr>
-          <p:cNvPr id="16" name="Text 13"/>
-          <p:cNvSpPr txBox="1"/>
-          <p:nvPr/>
-        </p:nvSpPr>
-        <p:spPr>
-          <a:xfrm>
-            <a:off x="8766048" y="2194560"/>
-            <a:ext cx="1685544" cy="731520"/>
-          </a:xfrm>
-          <a:prstGeom prst="rect">
-            <a:avLst/>
-          </a:prstGeom>
-          <a:noFill/>
-          <a:ln/>
-        </p:spPr>
-        <p:txBody>
-          <a:bodyPr wrap="square" lIns="0" tIns="0" rIns="0" bIns="0" rtlCol="0" anchor="ctr"/>
-          <a:lstStyle/>
-          <a:p>
-            <a:pPr indent="0" marL="0">
-              <a:buNone/>
-            </a:pPr>
-            <a:r>
-              <a:rPr lang="en-US" sz="1800" dirty="0">
-                <a:solidFill>
-                  <a:srgbClr val="1D1D1F"/>
-                </a:solidFill>
-              </a:rPr>
-              <a:t>Rag</a:t>
-            </a:r>
-            <a:endParaRPr lang="en-US" sz="1800" dirty="0"/>
-          </a:p>
-        </p:txBody>
-      </p:sp>
-      <p:sp>
-        <p:nvSpPr>
-          <p:cNvPr id="17" name="Text 14"/>
-          <p:cNvSpPr txBox="1"/>
-          <p:nvPr/>
-        </p:nvSpPr>
-        <p:spPr>
-          <a:xfrm>
-            <a:off x="10451592" y="2194560"/>
-            <a:ext cx="1005840" cy="731520"/>
-          </a:xfrm>
-          <a:prstGeom prst="rect">
-            <a:avLst/>
-          </a:prstGeom>
-          <a:noFill/>
-          <a:ln/>
-        </p:spPr>
-        <p:txBody>
-          <a:bodyPr wrap="square" lIns="0" tIns="0" rIns="0" bIns="0" rtlCol="0" anchor="ctr"/>
-          <a:lstStyle/>
-          <a:p>
-            <a:pPr algn="r" indent="0" marL="0">
-              <a:buNone/>
-            </a:pPr>
-            <a:r>
-              <a:rPr lang="en-US" sz="1300" dirty="0">
-                <a:solidFill>
-                  <a:srgbClr val="55555B"/>
-                </a:solidFill>
-              </a:rPr>
-              <a:t>healthy</a:t>
-            </a:r>
-            <a:endParaRPr lang="en-US" sz="1300" dirty="0"/>
-          </a:p>
-        </p:txBody>
-      </p:sp>
-      <p:sp>
-        <p:nvSpPr>
-          <p:cNvPr id="18" name="Shape 15"/>
-          <p:cNvSpPr/>
-          <p:nvPr/>
-        </p:nvSpPr>
-        <p:spPr>
-          <a:xfrm>
-            <a:off x="548640" y="3154680"/>
-            <a:ext cx="3514344" cy="731520"/>
-          </a:xfrm>
-          <a:prstGeom prst="roundRect">
-            <a:avLst>
-              <a:gd name="adj" fmla="val 12500"/>
-            </a:avLst>
-          </a:prstGeom>
-          <a:solidFill>
-            <a:srgbClr val="FFFFFF"/>
-          </a:solidFill>
-          <a:ln w="9525">
-            <a:solidFill>
-              <a:srgbClr val="D9D9DE"/>
-            </a:solidFill>
-            <a:prstDash val="solid"/>
-          </a:ln>
-        </p:spPr>
-      </p:sp>
-      <p:sp>
-        <p:nvSpPr>
-          <p:cNvPr id="19" name="Shape 16"/>
-          <p:cNvSpPr/>
-          <p:nvPr/>
-        </p:nvSpPr>
-        <p:spPr>
-          <a:xfrm>
-            <a:off x="777240" y="3401568"/>
-            <a:ext cx="237744" cy="237744"/>
-          </a:xfrm>
-          <a:prstGeom prst="ellipse">
-            <a:avLst/>
-          </a:prstGeom>
-          <a:solidFill>
-            <a:srgbClr val="1E9E6A"/>
-          </a:solidFill>
-          <a:ln w="12700">
-            <a:solidFill>
-              <a:srgbClr val="1E9E6A"/>
-            </a:solidFill>
-            <a:prstDash val="solid"/>
-          </a:ln>
-        </p:spPr>
-      </p:sp>
-      <p:sp>
-        <p:nvSpPr>
-          <p:cNvPr id="20" name="Text 17"/>
-          <p:cNvSpPr txBox="1"/>
-          <p:nvPr/>
-        </p:nvSpPr>
-        <p:spPr>
-          <a:xfrm>
-            <a:off x="1188720" y="3154680"/>
-            <a:ext cx="1685544" cy="731520"/>
-          </a:xfrm>
-          <a:prstGeom prst="rect">
-            <a:avLst/>
-          </a:prstGeom>
-          <a:noFill/>
-          <a:ln/>
-        </p:spPr>
-        <p:txBody>
-          <a:bodyPr wrap="square" lIns="0" tIns="0" rIns="0" bIns="0" rtlCol="0" anchor="ctr"/>
-          <a:lstStyle/>
-          <a:p>
-            <a:pPr indent="0" marL="0">
-              <a:buNone/>
-            </a:pPr>
-            <a:r>
-              <a:rPr lang="en-US" sz="1800" dirty="0">
-                <a:solidFill>
-                  <a:srgbClr val="1D1D1F"/>
-                </a:solidFill>
-              </a:rPr>
-              <a:t>Llm</a:t>
-            </a:r>
-            <a:endParaRPr lang="en-US" sz="1800" dirty="0"/>
-          </a:p>
-        </p:txBody>
-      </p:sp>
-      <p:sp>
-        <p:nvSpPr>
-          <p:cNvPr id="21" name="Text 18"/>
-          <p:cNvSpPr txBox="1"/>
-          <p:nvPr/>
-        </p:nvSpPr>
-        <p:spPr>
-          <a:xfrm>
-            <a:off x="2874264" y="3154680"/>
-            <a:ext cx="1005840" cy="731520"/>
-          </a:xfrm>
-          <a:prstGeom prst="rect">
-            <a:avLst/>
-          </a:prstGeom>
-          <a:noFill/>
-          <a:ln/>
-        </p:spPr>
-        <p:txBody>
-          <a:bodyPr wrap="square" lIns="0" tIns="0" rIns="0" bIns="0" rtlCol="0" anchor="ctr"/>
-          <a:lstStyle/>
-          <a:p>
-            <a:pPr algn="r" indent="0" marL="0">
-              <a:buNone/>
-            </a:pPr>
-            <a:r>
-              <a:rPr lang="en-US" sz="1300" dirty="0">
-                <a:solidFill>
-                  <a:srgbClr val="55555B"/>
-                </a:solidFill>
-              </a:rPr>
-              <a:t>healthy</a:t>
-            </a:r>
-            <a:endParaRPr lang="en-US" sz="1300" dirty="0"/>
-          </a:p>
-        </p:txBody>
-      </p:sp>
-      <p:sp>
-        <p:nvSpPr>
-          <p:cNvPr id="22" name="Shape 19"/>
-          <p:cNvSpPr/>
-          <p:nvPr/>
-        </p:nvSpPr>
-        <p:spPr>
-          <a:xfrm>
-            <a:off x="4337304" y="3154680"/>
-            <a:ext cx="3514344" cy="731520"/>
-          </a:xfrm>
-          <a:prstGeom prst="roundRect">
-            <a:avLst>
-              <a:gd name="adj" fmla="val 12500"/>
-            </a:avLst>
-          </a:prstGeom>
-          <a:solidFill>
-            <a:srgbClr val="FFFFFF"/>
-          </a:solidFill>
-          <a:ln w="9525">
-            <a:solidFill>
-              <a:srgbClr val="D9D9DE"/>
-            </a:solidFill>
-            <a:prstDash val="solid"/>
-          </a:ln>
-        </p:spPr>
-      </p:sp>
-      <p:sp>
-        <p:nvSpPr>
-          <p:cNvPr id="23" name="Shape 20"/>
-          <p:cNvSpPr/>
-          <p:nvPr/>
-        </p:nvSpPr>
-        <p:spPr>
-          <a:xfrm>
-            <a:off x="4565904" y="3401568"/>
-            <a:ext cx="237744" cy="237744"/>
-          </a:xfrm>
-          <a:prstGeom prst="ellipse">
-            <a:avLst/>
-          </a:prstGeom>
-          <a:solidFill>
-            <a:srgbClr val="1E9E6A"/>
-          </a:solidFill>
-          <a:ln w="12700">
-            <a:solidFill>
-              <a:srgbClr val="1E9E6A"/>
-            </a:solidFill>
-            <a:prstDash val="solid"/>
-          </a:ln>
-        </p:spPr>
-      </p:sp>
-      <p:sp>
-        <p:nvSpPr>
-          <p:cNvPr id="24" name="Text 21"/>
-          <p:cNvSpPr txBox="1"/>
-          <p:nvPr/>
-        </p:nvSpPr>
-        <p:spPr>
-          <a:xfrm>
-            <a:off x="4977384" y="3154680"/>
-            <a:ext cx="1685544" cy="731520"/>
-          </a:xfrm>
-          <a:prstGeom prst="rect">
-            <a:avLst/>
-          </a:prstGeom>
-          <a:noFill/>
-          <a:ln/>
-        </p:spPr>
-        <p:txBody>
-          <a:bodyPr wrap="square" lIns="0" tIns="0" rIns="0" bIns="0" rtlCol="0" anchor="ctr"/>
-          <a:lstStyle/>
-          <a:p>
-            <a:pPr indent="0" marL="0">
-              <a:buNone/>
-            </a:pPr>
-            <a:r>
-              <a:rPr lang="en-US" sz="1800" dirty="0">
-                <a:solidFill>
-                  <a:srgbClr val="1D1D1F"/>
-                </a:solidFill>
-              </a:rPr>
-              <a:t>Orchestrator</a:t>
-            </a:r>
-            <a:endParaRPr lang="en-US" sz="1800" dirty="0"/>
-          </a:p>
-        </p:txBody>
-      </p:sp>
-      <p:sp>
-        <p:nvSpPr>
-          <p:cNvPr id="25" name="Text 22"/>
-          <p:cNvSpPr txBox="1"/>
-          <p:nvPr/>
-        </p:nvSpPr>
-        <p:spPr>
-          <a:xfrm>
-            <a:off x="6662928" y="3154680"/>
-            <a:ext cx="1005840" cy="731520"/>
-          </a:xfrm>
-          <a:prstGeom prst="rect">
-            <a:avLst/>
-          </a:prstGeom>
-          <a:noFill/>
-          <a:ln/>
-        </p:spPr>
-        <p:txBody>
-          <a:bodyPr wrap="square" lIns="0" tIns="0" rIns="0" bIns="0" rtlCol="0" anchor="ctr"/>
-          <a:lstStyle/>
-          <a:p>
-            <a:pPr algn="r" indent="0" marL="0">
-              <a:buNone/>
-            </a:pPr>
-            <a:r>
-              <a:rPr lang="en-US" sz="1300" dirty="0">
-                <a:solidFill>
-                  <a:srgbClr val="55555B"/>
-                </a:solidFill>
-              </a:rPr>
-              <a:t>healthy</a:t>
-            </a:r>
-            <a:endParaRPr lang="en-US" sz="1300" dirty="0"/>
-          </a:p>
-        </p:txBody>
-      </p:sp>
-      <p:sp>
-        <p:nvSpPr>
-          <p:cNvPr id="26" name="Shape 23"/>
-          <p:cNvSpPr/>
-          <p:nvPr/>
-        </p:nvSpPr>
-        <p:spPr>
-          <a:xfrm>
-            <a:off x="8125968" y="3154680"/>
-            <a:ext cx="3514344" cy="731520"/>
-          </a:xfrm>
-          <a:prstGeom prst="roundRect">
-            <a:avLst>
-              <a:gd name="adj" fmla="val 12500"/>
-            </a:avLst>
-          </a:prstGeom>
-          <a:solidFill>
-            <a:srgbClr val="FFFFFF"/>
-          </a:solidFill>
-          <a:ln w="9525">
-            <a:solidFill>
-              <a:srgbClr val="D9D9DE"/>
-            </a:solidFill>
-            <a:prstDash val="solid"/>
-          </a:ln>
-        </p:spPr>
-      </p:sp>
-      <p:sp>
-        <p:nvSpPr>
-          <p:cNvPr id="27" name="Shape 24"/>
-          <p:cNvSpPr/>
-          <p:nvPr/>
-        </p:nvSpPr>
-        <p:spPr>
-          <a:xfrm>
-            <a:off x="8354568" y="3401568"/>
-            <a:ext cx="237744" cy="237744"/>
-          </a:xfrm>
-          <a:prstGeom prst="ellipse">
-            <a:avLst/>
-          </a:prstGeom>
-          <a:solidFill>
-            <a:srgbClr val="1E9E6A"/>
-          </a:solidFill>
-          <a:ln w="12700">
-            <a:solidFill>
-              <a:srgbClr val="1E9E6A"/>
-            </a:solidFill>
-            <a:prstDash val="solid"/>
-          </a:ln>
-        </p:spPr>
-      </p:sp>
-      <p:sp>
-        <p:nvSpPr>
-          <p:cNvPr id="28" name="Text 25"/>
-          <p:cNvSpPr txBox="1"/>
-          <p:nvPr/>
-        </p:nvSpPr>
-        <p:spPr>
-          <a:xfrm>
-            <a:off x="8766048" y="3154680"/>
-            <a:ext cx="1685544" cy="731520"/>
-          </a:xfrm>
-          <a:prstGeom prst="rect">
-            <a:avLst/>
-          </a:prstGeom>
-          <a:noFill/>
-          <a:ln/>
-        </p:spPr>
-        <p:txBody>
-          <a:bodyPr wrap="square" lIns="0" tIns="0" rIns="0" bIns="0" rtlCol="0" anchor="ctr"/>
-          <a:lstStyle/>
-          <a:p>
-            <a:pPr indent="0" marL="0">
-              <a:buNone/>
-            </a:pPr>
-            <a:r>
-              <a:rPr lang="en-US" sz="1800" dirty="0">
-                <a:solidFill>
-                  <a:srgbClr val="1D1D1F"/>
-                </a:solidFill>
-              </a:rPr>
-              <a:t>Eval</a:t>
-            </a:r>
-            <a:endParaRPr lang="en-US" sz="1800" dirty="0"/>
-          </a:p>
-        </p:txBody>
-      </p:sp>
-      <p:sp>
-        <p:nvSpPr>
-          <p:cNvPr id="29" name="Text 26"/>
-          <p:cNvSpPr txBox="1"/>
-          <p:nvPr/>
-        </p:nvSpPr>
-        <p:spPr>
-          <a:xfrm>
-            <a:off x="10451592" y="3154680"/>
-            <a:ext cx="1005840" cy="731520"/>
-          </a:xfrm>
-          <a:prstGeom prst="rect">
-            <a:avLst/>
-          </a:prstGeom>
-          <a:noFill/>
-          <a:ln/>
-        </p:spPr>
-        <p:txBody>
-          <a:bodyPr wrap="square" lIns="0" tIns="0" rIns="0" bIns="0" rtlCol="0" anchor="ctr"/>
-          <a:lstStyle/>
-          <a:p>
-            <a:pPr algn="r" indent="0" marL="0">
-              <a:buNone/>
-            </a:pPr>
-            <a:r>
-              <a:rPr lang="en-US" sz="1300" dirty="0">
-                <a:solidFill>
-                  <a:srgbClr val="55555B"/>
-                </a:solidFill>
-              </a:rPr>
-              <a:t>healthy</a:t>
-            </a:r>
-            <a:endParaRPr lang="en-US" sz="1300" dirty="0"/>
-          </a:p>
-        </p:txBody>
-      </p:sp>
-      <p:sp>
-        <p:nvSpPr>
-          <p:cNvPr id="30" name="Shape 27"/>
-          <p:cNvSpPr/>
-          <p:nvPr/>
-        </p:nvSpPr>
-        <p:spPr>
-          <a:xfrm>
-            <a:off x="548640" y="4160520"/>
-            <a:ext cx="11091672" cy="2011680"/>
-          </a:xfrm>
-          <a:prstGeom prst="roundRect">
-            <a:avLst>
-              <a:gd name="adj" fmla="val 4545"/>
-            </a:avLst>
-          </a:prstGeom>
-          <a:solidFill>
-            <a:srgbClr val="FFFFFF"/>
-          </a:solidFill>
-          <a:ln w="9525">
-            <a:solidFill>
-              <a:srgbClr val="D9D9DE"/>
-            </a:solidFill>
-            <a:prstDash val="solid"/>
-          </a:ln>
-          <a:effectLst>
-            <a:outerShdw sx="100000" sy="100000" kx="0" ky="0" algn="bl" rotWithShape="0" blurRad="76200" dist="12700" dir="5400000">
-              <a:srgbClr val="000000">
-                <a:alpha val="8000"/>
-              </a:srgbClr>
-            </a:outerShdw>
-          </a:effectLst>
-        </p:spPr>
-      </p:sp>
-      <p:sp>
-        <p:nvSpPr>
-          <p:cNvPr id="31" name="Text 28"/>
-          <p:cNvSpPr txBox="1"/>
-          <p:nvPr/>
-        </p:nvSpPr>
-        <p:spPr>
-          <a:xfrm>
-            <a:off x="731520" y="4297680"/>
-            <a:ext cx="10725912" cy="411480"/>
-          </a:xfrm>
-          <a:prstGeom prst="rect">
-            <a:avLst/>
-          </a:prstGeom>
-          <a:noFill/>
-          <a:ln/>
-        </p:spPr>
-        <p:txBody>
-          <a:bodyPr wrap="square" lIns="0" tIns="0" rIns="0" bIns="0" rtlCol="0" anchor="t"/>
-          <a:lstStyle/>
-          <a:p>
-            <a:pPr indent="0" marL="0">
-              <a:buNone/>
-            </a:pPr>
-            <a:r>
-              <a:rPr lang="en-US" sz="1800" b="1" dirty="0">
-                <a:solidFill>
-                  <a:srgbClr val="1D1D1F"/>
-                </a:solidFill>
-              </a:rPr>
-              <a:t>What to demo</a:t>
-            </a:r>
-            <a:endParaRPr lang="en-US" sz="1800" dirty="0"/>
-          </a:p>
-        </p:txBody>
-      </p:sp>
-      <p:sp>
-        <p:nvSpPr>
-          <p:cNvPr id="32" name="Text 29"/>
-          <p:cNvSpPr txBox="1"/>
-          <p:nvPr/>
-        </p:nvSpPr>
-        <p:spPr>
-          <a:xfrm>
-            <a:off x="731520" y="4709160"/>
-            <a:ext cx="10725912" cy="1353312"/>
-          </a:xfrm>
-          <a:prstGeom prst="rect">
-            <a:avLst/>
-          </a:prstGeom>
-          <a:noFill/>
-          <a:ln/>
-        </p:spPr>
-        <p:txBody>
-          <a:bodyPr wrap="square" lIns="0" tIns="0" rIns="0" bIns="0" rtlCol="0" anchor="t"/>
-          <a:lstStyle/>
-          <a:p>
-            <a:pPr indent="0" marL="0">
-              <a:buNone/>
-            </a:pPr>
-            <a:r>
-              <a:rPr lang="en-US" sz="1500" dirty="0">
-                <a:solidFill>
-                  <a:srgbClr val="1D1D1F"/>
-                </a:solidFill>
-              </a:rPr>
-              <a:t>Ask: "Why does itsdangerous keep SHA-1 as its default digest?" and show the cited answer and the evidence chain.</a:t>
-            </a:r>
-            <a:endParaRPr lang="en-US" sz="1500" dirty="0"/>
-          </a:p>
-          <a:p>
-            <a:pPr indent="0" marL="0">
-              <a:buNone/>
-            </a:pPr>
-            <a:r>
-              <a:rPr lang="en-US" sz="1500" dirty="0">
-                <a:solidFill>
-                  <a:srgbClr val="1D1D1F"/>
-                </a:solidFill>
-              </a:rPr>
-              <a:t>Evaluation page: the held-out run, per-mode leaderboard, and which model is best for what.</a:t>
-            </a:r>
-            <a:endParaRPr lang="en-US" sz="1500" dirty="0"/>
-          </a:p>
-          <a:p>
-            <a:pPr indent="0" marL="0">
-              <a:buNone/>
-            </a:pPr>
-            <a:r>
-              <a:rPr lang="en-US" sz="1500" dirty="0">
-                <a:solidFill>
-                  <a:srgbClr val="1D1D1F"/>
-                </a:solidFill>
-              </a:rPr>
-              <a:t>Repositories page: the three indexed repositories (demo, itsdangerous, Nexus).</a:t>
-            </a:r>
-            <a:endParaRPr lang="en-US" sz="1500" dirty="0"/>
-          </a:p>
-        </p:txBody>
-      </p:sp>
-      <p:sp>
-        <p:nvSpPr>
-          <p:cNvPr id="25" name="Slide Number Placeholder 0"/>
-          <p:cNvSpPr>
-            <a:spLocks noGrp="1"/>
-          </p:cNvSpPr>
-          <p:nvPr>
-            <p:ph type="sldNum" sz="quarter" idx="4294967295"/>
-          </p:nvPr>
-        </p:nvSpPr>
-        <p:spPr>
-          <a:xfrm>
-            <a:off x="10725912" y="6419088"/>
-            <a:ext cx="914400" cy="274320"/>
-          </a:xfrm>
-          <a:prstGeom prst="rect">
-            <a:avLst/>
-          </a:prstGeom>
-          <a:extLst>
-            <a:ext uri="{C572A759-6A51-4108-AA02-DFA0A04FC94B}">
-              <ma14:wrappingTextBoxFlag xmlns:ma14="http://schemas.microsoft.com/office/mac/drawingml/2011/main" val="0"/>
-            </a:ext>
-          </a:extLst>
-        </p:spPr>
-        <p:txBody>
-          <a:bodyPr/>
-          <a:lstStyle>
-            <a:lvl1pPr>
-              <a:defRPr sz="1100">
-                <a:solidFill>
-                  <a:srgbClr val="55555B"/>
-                </a:solidFill>
-                <a:latin typeface="Calibri"/>
-                <a:ea typeface="Calibri"/>
-                <a:cs typeface="Calibri"/>
-              </a:defRPr>
-            </a:lvl1pPr>
-          </a:lstStyle>
-          <a:p>
-            <a:pPr algn="r"/>
-            <a:fld id="{F7021451-1387-4CA6-816F-3879F97B5CBC}" type="slidenum">
-              <a:rPr b="0" lang="en-US"/>
               <a:t>13</a:t>
             </a:fld>
             <a:endParaRPr lang="en-US"/>
@@ -13004,8 +12780,8 @@
         </p:nvSpPr>
         <p:spPr>
           <a:xfrm>
-            <a:off x="548640" y="2194560"/>
-            <a:ext cx="11091672" cy="1188720"/>
+            <a:off x="548640" y="365760"/>
+            <a:ext cx="11091672" cy="274320"/>
           </a:xfrm>
           <a:prstGeom prst="rect">
             <a:avLst/>
@@ -13021,14 +12797,14 @@
               <a:buNone/>
             </a:pPr>
             <a:r>
-              <a:rPr lang="en-US" sz="6400" b="1" dirty="0">
-                <a:solidFill>
-                  <a:srgbClr val="1D1D1F"/>
+              <a:rPr lang="en-US" sz="1200" b="1" spc="200" kern="0" dirty="0">
+                <a:solidFill>
+                  <a:srgbClr val="0071E3"/>
                 </a:solidFill>
               </a:rPr>
-              <a:t>Questions?</a:t>
-            </a:r>
-            <a:endParaRPr lang="en-US" sz="6400" dirty="0"/>
+              <a:t>LIVE SYSTEM</a:t>
+            </a:r>
+            <a:endParaRPr lang="en-US" sz="1200" dirty="0"/>
           </a:p>
         </p:txBody>
       </p:sp>
@@ -13040,8 +12816,8 @@
         </p:nvSpPr>
         <p:spPr>
           <a:xfrm>
-            <a:off x="548640" y="3566160"/>
-            <a:ext cx="11091672" cy="457200"/>
+            <a:off x="548640" y="658368"/>
+            <a:ext cx="11091672" cy="731520"/>
           </a:xfrm>
           <a:prstGeom prst="rect">
             <a:avLst/>
@@ -13057,14 +12833,14 @@
               <a:buNone/>
             </a:pPr>
             <a:r>
-              <a:rPr lang="en-US" sz="2200" dirty="0">
-                <a:solidFill>
-                  <a:srgbClr val="55555B"/>
+              <a:rPr lang="en-US" sz="3600" b="1" dirty="0">
+                <a:solidFill>
+                  <a:srgbClr val="1D1D1F"/>
                 </a:solidFill>
               </a:rPr>
-              <a:t>github.com/IATESPAGHETTI/Code_Origin</a:t>
-            </a:r>
-            <a:endParaRPr lang="en-US" sz="2200" dirty="0"/>
+              <a:t>The running stack</a:t>
+            </a:r>
+            <a:endParaRPr lang="en-US" sz="3600" dirty="0"/>
           </a:p>
         </p:txBody>
       </p:sp>
@@ -13076,8 +12852,8 @@
         </p:nvSpPr>
         <p:spPr>
           <a:xfrm>
-            <a:off x="548640" y="4297680"/>
-            <a:ext cx="11091672" cy="457200"/>
+            <a:off x="548640" y="1371600"/>
+            <a:ext cx="11091672" cy="548640"/>
           </a:xfrm>
           <a:prstGeom prst="rect">
             <a:avLst/>
@@ -13086,21 +12862,899 @@
           <a:ln/>
         </p:spPr>
         <p:txBody>
-          <a:bodyPr wrap="square" lIns="0" tIns="0" rIns="0" bIns="0" rtlCol="0" anchor="ctr"/>
+          <a:bodyPr wrap="square" lIns="0" tIns="0" rIns="0" bIns="0" rtlCol="0" anchor="t"/>
           <a:lstStyle/>
           <a:p>
             <a:pPr indent="0" marL="0">
               <a:buNone/>
             </a:pPr>
             <a:r>
+              <a:rPr lang="en-US" sz="1600" dirty="0">
+                <a:solidFill>
+                  <a:srgbClr val="55555B"/>
+                </a:solidFill>
+              </a:rPr>
+              <a:t>Shown live from the website during the talk (health is checked through the gateway every few seconds).</a:t>
+            </a:r>
+            <a:endParaRPr lang="en-US" sz="1600" dirty="0"/>
+          </a:p>
+        </p:txBody>
+      </p:sp>
+      <p:sp>
+        <p:nvSpPr>
+          <p:cNvPr id="6" name="Shape 3"/>
+          <p:cNvSpPr/>
+          <p:nvPr/>
+        </p:nvSpPr>
+        <p:spPr>
+          <a:xfrm>
+            <a:off x="548640" y="2194560"/>
+            <a:ext cx="3514344" cy="731520"/>
+          </a:xfrm>
+          <a:prstGeom prst="roundRect">
+            <a:avLst>
+              <a:gd name="adj" fmla="val 12500"/>
+            </a:avLst>
+          </a:prstGeom>
+          <a:solidFill>
+            <a:srgbClr val="FFFFFF"/>
+          </a:solidFill>
+          <a:ln w="9525">
+            <a:solidFill>
+              <a:srgbClr val="D9D9DE"/>
+            </a:solidFill>
+            <a:prstDash val="solid"/>
+          </a:ln>
+        </p:spPr>
+      </p:sp>
+      <p:sp>
+        <p:nvSpPr>
+          <p:cNvPr id="7" name="Shape 4"/>
+          <p:cNvSpPr/>
+          <p:nvPr/>
+        </p:nvSpPr>
+        <p:spPr>
+          <a:xfrm>
+            <a:off x="777240" y="2441448"/>
+            <a:ext cx="237744" cy="237744"/>
+          </a:xfrm>
+          <a:prstGeom prst="ellipse">
+            <a:avLst/>
+          </a:prstGeom>
+          <a:solidFill>
+            <a:srgbClr val="1E9E6A"/>
+          </a:solidFill>
+          <a:ln w="12700">
+            <a:solidFill>
+              <a:srgbClr val="1E9E6A"/>
+            </a:solidFill>
+            <a:prstDash val="solid"/>
+          </a:ln>
+        </p:spPr>
+      </p:sp>
+      <p:sp>
+        <p:nvSpPr>
+          <p:cNvPr id="8" name="Text 5"/>
+          <p:cNvSpPr txBox="1"/>
+          <p:nvPr/>
+        </p:nvSpPr>
+        <p:spPr>
+          <a:xfrm>
+            <a:off x="1188720" y="2194560"/>
+            <a:ext cx="1685544" cy="731520"/>
+          </a:xfrm>
+          <a:prstGeom prst="rect">
+            <a:avLst/>
+          </a:prstGeom>
+          <a:noFill/>
+          <a:ln/>
+        </p:spPr>
+        <p:txBody>
+          <a:bodyPr wrap="square" lIns="0" tIns="0" rIns="0" bIns="0" rtlCol="0" anchor="ctr"/>
+          <a:lstStyle/>
+          <a:p>
+            <a:pPr indent="0" marL="0">
+              <a:buNone/>
+            </a:pPr>
+            <a:r>
               <a:rPr lang="en-US" sz="1800" dirty="0">
                 <a:solidFill>
-                  <a:srgbClr val="0071E3"/>
+                  <a:srgbClr val="1D1D1F"/>
                 </a:solidFill>
               </a:rPr>
-              <a:t>We claim: supported on one real repository for 7B models, not yet general.</a:t>
+              <a:t>Gateway</a:t>
             </a:r>
             <a:endParaRPr lang="en-US" sz="1800" dirty="0"/>
+          </a:p>
+        </p:txBody>
+      </p:sp>
+      <p:sp>
+        <p:nvSpPr>
+          <p:cNvPr id="9" name="Text 6"/>
+          <p:cNvSpPr txBox="1"/>
+          <p:nvPr/>
+        </p:nvSpPr>
+        <p:spPr>
+          <a:xfrm>
+            <a:off x="2874264" y="2194560"/>
+            <a:ext cx="1005840" cy="731520"/>
+          </a:xfrm>
+          <a:prstGeom prst="rect">
+            <a:avLst/>
+          </a:prstGeom>
+          <a:noFill/>
+          <a:ln/>
+        </p:spPr>
+        <p:txBody>
+          <a:bodyPr wrap="square" lIns="0" tIns="0" rIns="0" bIns="0" rtlCol="0" anchor="ctr"/>
+          <a:lstStyle/>
+          <a:p>
+            <a:pPr algn="r" indent="0" marL="0">
+              <a:buNone/>
+            </a:pPr>
+            <a:r>
+              <a:rPr lang="en-US" sz="1300" dirty="0">
+                <a:solidFill>
+                  <a:srgbClr val="55555B"/>
+                </a:solidFill>
+              </a:rPr>
+              <a:t>healthy</a:t>
+            </a:r>
+            <a:endParaRPr lang="en-US" sz="1300" dirty="0"/>
+          </a:p>
+        </p:txBody>
+      </p:sp>
+      <p:sp>
+        <p:nvSpPr>
+          <p:cNvPr id="10" name="Shape 7"/>
+          <p:cNvSpPr/>
+          <p:nvPr/>
+        </p:nvSpPr>
+        <p:spPr>
+          <a:xfrm>
+            <a:off x="4337304" y="2194560"/>
+            <a:ext cx="3514344" cy="731520"/>
+          </a:xfrm>
+          <a:prstGeom prst="roundRect">
+            <a:avLst>
+              <a:gd name="adj" fmla="val 12500"/>
+            </a:avLst>
+          </a:prstGeom>
+          <a:solidFill>
+            <a:srgbClr val="FFFFFF"/>
+          </a:solidFill>
+          <a:ln w="9525">
+            <a:solidFill>
+              <a:srgbClr val="D9D9DE"/>
+            </a:solidFill>
+            <a:prstDash val="solid"/>
+          </a:ln>
+        </p:spPr>
+      </p:sp>
+      <p:sp>
+        <p:nvSpPr>
+          <p:cNvPr id="11" name="Shape 8"/>
+          <p:cNvSpPr/>
+          <p:nvPr/>
+        </p:nvSpPr>
+        <p:spPr>
+          <a:xfrm>
+            <a:off x="4565904" y="2441448"/>
+            <a:ext cx="237744" cy="237744"/>
+          </a:xfrm>
+          <a:prstGeom prst="ellipse">
+            <a:avLst/>
+          </a:prstGeom>
+          <a:solidFill>
+            <a:srgbClr val="1E9E6A"/>
+          </a:solidFill>
+          <a:ln w="12700">
+            <a:solidFill>
+              <a:srgbClr val="1E9E6A"/>
+            </a:solidFill>
+            <a:prstDash val="solid"/>
+          </a:ln>
+        </p:spPr>
+      </p:sp>
+      <p:sp>
+        <p:nvSpPr>
+          <p:cNvPr id="12" name="Text 9"/>
+          <p:cNvSpPr txBox="1"/>
+          <p:nvPr/>
+        </p:nvSpPr>
+        <p:spPr>
+          <a:xfrm>
+            <a:off x="4977384" y="2194560"/>
+            <a:ext cx="1685544" cy="731520"/>
+          </a:xfrm>
+          <a:prstGeom prst="rect">
+            <a:avLst/>
+          </a:prstGeom>
+          <a:noFill/>
+          <a:ln/>
+        </p:spPr>
+        <p:txBody>
+          <a:bodyPr wrap="square" lIns="0" tIns="0" rIns="0" bIns="0" rtlCol="0" anchor="ctr"/>
+          <a:lstStyle/>
+          <a:p>
+            <a:pPr indent="0" marL="0">
+              <a:buNone/>
+            </a:pPr>
+            <a:r>
+              <a:rPr lang="en-US" sz="1800" dirty="0">
+                <a:solidFill>
+                  <a:srgbClr val="1D1D1F"/>
+                </a:solidFill>
+              </a:rPr>
+              <a:t>Ingest</a:t>
+            </a:r>
+            <a:endParaRPr lang="en-US" sz="1800" dirty="0"/>
+          </a:p>
+        </p:txBody>
+      </p:sp>
+      <p:sp>
+        <p:nvSpPr>
+          <p:cNvPr id="13" name="Text 10"/>
+          <p:cNvSpPr txBox="1"/>
+          <p:nvPr/>
+        </p:nvSpPr>
+        <p:spPr>
+          <a:xfrm>
+            <a:off x="6662928" y="2194560"/>
+            <a:ext cx="1005840" cy="731520"/>
+          </a:xfrm>
+          <a:prstGeom prst="rect">
+            <a:avLst/>
+          </a:prstGeom>
+          <a:noFill/>
+          <a:ln/>
+        </p:spPr>
+        <p:txBody>
+          <a:bodyPr wrap="square" lIns="0" tIns="0" rIns="0" bIns="0" rtlCol="0" anchor="ctr"/>
+          <a:lstStyle/>
+          <a:p>
+            <a:pPr algn="r" indent="0" marL="0">
+              <a:buNone/>
+            </a:pPr>
+            <a:r>
+              <a:rPr lang="en-US" sz="1300" dirty="0">
+                <a:solidFill>
+                  <a:srgbClr val="55555B"/>
+                </a:solidFill>
+              </a:rPr>
+              <a:t>healthy</a:t>
+            </a:r>
+            <a:endParaRPr lang="en-US" sz="1300" dirty="0"/>
+          </a:p>
+        </p:txBody>
+      </p:sp>
+      <p:sp>
+        <p:nvSpPr>
+          <p:cNvPr id="14" name="Shape 11"/>
+          <p:cNvSpPr/>
+          <p:nvPr/>
+        </p:nvSpPr>
+        <p:spPr>
+          <a:xfrm>
+            <a:off x="8125968" y="2194560"/>
+            <a:ext cx="3514344" cy="731520"/>
+          </a:xfrm>
+          <a:prstGeom prst="roundRect">
+            <a:avLst>
+              <a:gd name="adj" fmla="val 12500"/>
+            </a:avLst>
+          </a:prstGeom>
+          <a:solidFill>
+            <a:srgbClr val="FFFFFF"/>
+          </a:solidFill>
+          <a:ln w="9525">
+            <a:solidFill>
+              <a:srgbClr val="D9D9DE"/>
+            </a:solidFill>
+            <a:prstDash val="solid"/>
+          </a:ln>
+        </p:spPr>
+      </p:sp>
+      <p:sp>
+        <p:nvSpPr>
+          <p:cNvPr id="15" name="Shape 12"/>
+          <p:cNvSpPr/>
+          <p:nvPr/>
+        </p:nvSpPr>
+        <p:spPr>
+          <a:xfrm>
+            <a:off x="8354568" y="2441448"/>
+            <a:ext cx="237744" cy="237744"/>
+          </a:xfrm>
+          <a:prstGeom prst="ellipse">
+            <a:avLst/>
+          </a:prstGeom>
+          <a:solidFill>
+            <a:srgbClr val="1E9E6A"/>
+          </a:solidFill>
+          <a:ln w="12700">
+            <a:solidFill>
+              <a:srgbClr val="1E9E6A"/>
+            </a:solidFill>
+            <a:prstDash val="solid"/>
+          </a:ln>
+        </p:spPr>
+      </p:sp>
+      <p:sp>
+        <p:nvSpPr>
+          <p:cNvPr id="16" name="Text 13"/>
+          <p:cNvSpPr txBox="1"/>
+          <p:nvPr/>
+        </p:nvSpPr>
+        <p:spPr>
+          <a:xfrm>
+            <a:off x="8766048" y="2194560"/>
+            <a:ext cx="1685544" cy="731520"/>
+          </a:xfrm>
+          <a:prstGeom prst="rect">
+            <a:avLst/>
+          </a:prstGeom>
+          <a:noFill/>
+          <a:ln/>
+        </p:spPr>
+        <p:txBody>
+          <a:bodyPr wrap="square" lIns="0" tIns="0" rIns="0" bIns="0" rtlCol="0" anchor="ctr"/>
+          <a:lstStyle/>
+          <a:p>
+            <a:pPr indent="0" marL="0">
+              <a:buNone/>
+            </a:pPr>
+            <a:r>
+              <a:rPr lang="en-US" sz="1800" dirty="0">
+                <a:solidFill>
+                  <a:srgbClr val="1D1D1F"/>
+                </a:solidFill>
+              </a:rPr>
+              <a:t>Rag</a:t>
+            </a:r>
+            <a:endParaRPr lang="en-US" sz="1800" dirty="0"/>
+          </a:p>
+        </p:txBody>
+      </p:sp>
+      <p:sp>
+        <p:nvSpPr>
+          <p:cNvPr id="17" name="Text 14"/>
+          <p:cNvSpPr txBox="1"/>
+          <p:nvPr/>
+        </p:nvSpPr>
+        <p:spPr>
+          <a:xfrm>
+            <a:off x="10451592" y="2194560"/>
+            <a:ext cx="1005840" cy="731520"/>
+          </a:xfrm>
+          <a:prstGeom prst="rect">
+            <a:avLst/>
+          </a:prstGeom>
+          <a:noFill/>
+          <a:ln/>
+        </p:spPr>
+        <p:txBody>
+          <a:bodyPr wrap="square" lIns="0" tIns="0" rIns="0" bIns="0" rtlCol="0" anchor="ctr"/>
+          <a:lstStyle/>
+          <a:p>
+            <a:pPr algn="r" indent="0" marL="0">
+              <a:buNone/>
+            </a:pPr>
+            <a:r>
+              <a:rPr lang="en-US" sz="1300" dirty="0">
+                <a:solidFill>
+                  <a:srgbClr val="55555B"/>
+                </a:solidFill>
+              </a:rPr>
+              <a:t>healthy</a:t>
+            </a:r>
+            <a:endParaRPr lang="en-US" sz="1300" dirty="0"/>
+          </a:p>
+        </p:txBody>
+      </p:sp>
+      <p:sp>
+        <p:nvSpPr>
+          <p:cNvPr id="18" name="Shape 15"/>
+          <p:cNvSpPr/>
+          <p:nvPr/>
+        </p:nvSpPr>
+        <p:spPr>
+          <a:xfrm>
+            <a:off x="548640" y="3154680"/>
+            <a:ext cx="3514344" cy="731520"/>
+          </a:xfrm>
+          <a:prstGeom prst="roundRect">
+            <a:avLst>
+              <a:gd name="adj" fmla="val 12500"/>
+            </a:avLst>
+          </a:prstGeom>
+          <a:solidFill>
+            <a:srgbClr val="FFFFFF"/>
+          </a:solidFill>
+          <a:ln w="9525">
+            <a:solidFill>
+              <a:srgbClr val="D9D9DE"/>
+            </a:solidFill>
+            <a:prstDash val="solid"/>
+          </a:ln>
+        </p:spPr>
+      </p:sp>
+      <p:sp>
+        <p:nvSpPr>
+          <p:cNvPr id="19" name="Shape 16"/>
+          <p:cNvSpPr/>
+          <p:nvPr/>
+        </p:nvSpPr>
+        <p:spPr>
+          <a:xfrm>
+            <a:off x="777240" y="3401568"/>
+            <a:ext cx="237744" cy="237744"/>
+          </a:xfrm>
+          <a:prstGeom prst="ellipse">
+            <a:avLst/>
+          </a:prstGeom>
+          <a:solidFill>
+            <a:srgbClr val="1E9E6A"/>
+          </a:solidFill>
+          <a:ln w="12700">
+            <a:solidFill>
+              <a:srgbClr val="1E9E6A"/>
+            </a:solidFill>
+            <a:prstDash val="solid"/>
+          </a:ln>
+        </p:spPr>
+      </p:sp>
+      <p:sp>
+        <p:nvSpPr>
+          <p:cNvPr id="20" name="Text 17"/>
+          <p:cNvSpPr txBox="1"/>
+          <p:nvPr/>
+        </p:nvSpPr>
+        <p:spPr>
+          <a:xfrm>
+            <a:off x="1188720" y="3154680"/>
+            <a:ext cx="1685544" cy="731520"/>
+          </a:xfrm>
+          <a:prstGeom prst="rect">
+            <a:avLst/>
+          </a:prstGeom>
+          <a:noFill/>
+          <a:ln/>
+        </p:spPr>
+        <p:txBody>
+          <a:bodyPr wrap="square" lIns="0" tIns="0" rIns="0" bIns="0" rtlCol="0" anchor="ctr"/>
+          <a:lstStyle/>
+          <a:p>
+            <a:pPr indent="0" marL="0">
+              <a:buNone/>
+            </a:pPr>
+            <a:r>
+              <a:rPr lang="en-US" sz="1800" dirty="0">
+                <a:solidFill>
+                  <a:srgbClr val="1D1D1F"/>
+                </a:solidFill>
+              </a:rPr>
+              <a:t>Llm</a:t>
+            </a:r>
+            <a:endParaRPr lang="en-US" sz="1800" dirty="0"/>
+          </a:p>
+        </p:txBody>
+      </p:sp>
+      <p:sp>
+        <p:nvSpPr>
+          <p:cNvPr id="21" name="Text 18"/>
+          <p:cNvSpPr txBox="1"/>
+          <p:nvPr/>
+        </p:nvSpPr>
+        <p:spPr>
+          <a:xfrm>
+            <a:off x="2874264" y="3154680"/>
+            <a:ext cx="1005840" cy="731520"/>
+          </a:xfrm>
+          <a:prstGeom prst="rect">
+            <a:avLst/>
+          </a:prstGeom>
+          <a:noFill/>
+          <a:ln/>
+        </p:spPr>
+        <p:txBody>
+          <a:bodyPr wrap="square" lIns="0" tIns="0" rIns="0" bIns="0" rtlCol="0" anchor="ctr"/>
+          <a:lstStyle/>
+          <a:p>
+            <a:pPr algn="r" indent="0" marL="0">
+              <a:buNone/>
+            </a:pPr>
+            <a:r>
+              <a:rPr lang="en-US" sz="1300" dirty="0">
+                <a:solidFill>
+                  <a:srgbClr val="55555B"/>
+                </a:solidFill>
+              </a:rPr>
+              <a:t>healthy</a:t>
+            </a:r>
+            <a:endParaRPr lang="en-US" sz="1300" dirty="0"/>
+          </a:p>
+        </p:txBody>
+      </p:sp>
+      <p:sp>
+        <p:nvSpPr>
+          <p:cNvPr id="22" name="Shape 19"/>
+          <p:cNvSpPr/>
+          <p:nvPr/>
+        </p:nvSpPr>
+        <p:spPr>
+          <a:xfrm>
+            <a:off x="4337304" y="3154680"/>
+            <a:ext cx="3514344" cy="731520"/>
+          </a:xfrm>
+          <a:prstGeom prst="roundRect">
+            <a:avLst>
+              <a:gd name="adj" fmla="val 12500"/>
+            </a:avLst>
+          </a:prstGeom>
+          <a:solidFill>
+            <a:srgbClr val="FFFFFF"/>
+          </a:solidFill>
+          <a:ln w="9525">
+            <a:solidFill>
+              <a:srgbClr val="D9D9DE"/>
+            </a:solidFill>
+            <a:prstDash val="solid"/>
+          </a:ln>
+        </p:spPr>
+      </p:sp>
+      <p:sp>
+        <p:nvSpPr>
+          <p:cNvPr id="23" name="Shape 20"/>
+          <p:cNvSpPr/>
+          <p:nvPr/>
+        </p:nvSpPr>
+        <p:spPr>
+          <a:xfrm>
+            <a:off x="4565904" y="3401568"/>
+            <a:ext cx="237744" cy="237744"/>
+          </a:xfrm>
+          <a:prstGeom prst="ellipse">
+            <a:avLst/>
+          </a:prstGeom>
+          <a:solidFill>
+            <a:srgbClr val="1E9E6A"/>
+          </a:solidFill>
+          <a:ln w="12700">
+            <a:solidFill>
+              <a:srgbClr val="1E9E6A"/>
+            </a:solidFill>
+            <a:prstDash val="solid"/>
+          </a:ln>
+        </p:spPr>
+      </p:sp>
+      <p:sp>
+        <p:nvSpPr>
+          <p:cNvPr id="24" name="Text 21"/>
+          <p:cNvSpPr txBox="1"/>
+          <p:nvPr/>
+        </p:nvSpPr>
+        <p:spPr>
+          <a:xfrm>
+            <a:off x="4977384" y="3154680"/>
+            <a:ext cx="1685544" cy="731520"/>
+          </a:xfrm>
+          <a:prstGeom prst="rect">
+            <a:avLst/>
+          </a:prstGeom>
+          <a:noFill/>
+          <a:ln/>
+        </p:spPr>
+        <p:txBody>
+          <a:bodyPr wrap="square" lIns="0" tIns="0" rIns="0" bIns="0" rtlCol="0" anchor="ctr"/>
+          <a:lstStyle/>
+          <a:p>
+            <a:pPr indent="0" marL="0">
+              <a:buNone/>
+            </a:pPr>
+            <a:r>
+              <a:rPr lang="en-US" sz="1800" dirty="0">
+                <a:solidFill>
+                  <a:srgbClr val="1D1D1F"/>
+                </a:solidFill>
+              </a:rPr>
+              <a:t>Orchestrator</a:t>
+            </a:r>
+            <a:endParaRPr lang="en-US" sz="1800" dirty="0"/>
+          </a:p>
+        </p:txBody>
+      </p:sp>
+      <p:sp>
+        <p:nvSpPr>
+          <p:cNvPr id="25" name="Text 22"/>
+          <p:cNvSpPr txBox="1"/>
+          <p:nvPr/>
+        </p:nvSpPr>
+        <p:spPr>
+          <a:xfrm>
+            <a:off x="6662928" y="3154680"/>
+            <a:ext cx="1005840" cy="731520"/>
+          </a:xfrm>
+          <a:prstGeom prst="rect">
+            <a:avLst/>
+          </a:prstGeom>
+          <a:noFill/>
+          <a:ln/>
+        </p:spPr>
+        <p:txBody>
+          <a:bodyPr wrap="square" lIns="0" tIns="0" rIns="0" bIns="0" rtlCol="0" anchor="ctr"/>
+          <a:lstStyle/>
+          <a:p>
+            <a:pPr algn="r" indent="0" marL="0">
+              <a:buNone/>
+            </a:pPr>
+            <a:r>
+              <a:rPr lang="en-US" sz="1300" dirty="0">
+                <a:solidFill>
+                  <a:srgbClr val="55555B"/>
+                </a:solidFill>
+              </a:rPr>
+              <a:t>healthy</a:t>
+            </a:r>
+            <a:endParaRPr lang="en-US" sz="1300" dirty="0"/>
+          </a:p>
+        </p:txBody>
+      </p:sp>
+      <p:sp>
+        <p:nvSpPr>
+          <p:cNvPr id="26" name="Shape 23"/>
+          <p:cNvSpPr/>
+          <p:nvPr/>
+        </p:nvSpPr>
+        <p:spPr>
+          <a:xfrm>
+            <a:off x="8125968" y="3154680"/>
+            <a:ext cx="3514344" cy="731520"/>
+          </a:xfrm>
+          <a:prstGeom prst="roundRect">
+            <a:avLst>
+              <a:gd name="adj" fmla="val 12500"/>
+            </a:avLst>
+          </a:prstGeom>
+          <a:solidFill>
+            <a:srgbClr val="FFFFFF"/>
+          </a:solidFill>
+          <a:ln w="9525">
+            <a:solidFill>
+              <a:srgbClr val="D9D9DE"/>
+            </a:solidFill>
+            <a:prstDash val="solid"/>
+          </a:ln>
+        </p:spPr>
+      </p:sp>
+      <p:sp>
+        <p:nvSpPr>
+          <p:cNvPr id="27" name="Shape 24"/>
+          <p:cNvSpPr/>
+          <p:nvPr/>
+        </p:nvSpPr>
+        <p:spPr>
+          <a:xfrm>
+            <a:off x="8354568" y="3401568"/>
+            <a:ext cx="237744" cy="237744"/>
+          </a:xfrm>
+          <a:prstGeom prst="ellipse">
+            <a:avLst/>
+          </a:prstGeom>
+          <a:solidFill>
+            <a:srgbClr val="1E9E6A"/>
+          </a:solidFill>
+          <a:ln w="12700">
+            <a:solidFill>
+              <a:srgbClr val="1E9E6A"/>
+            </a:solidFill>
+            <a:prstDash val="solid"/>
+          </a:ln>
+        </p:spPr>
+      </p:sp>
+      <p:sp>
+        <p:nvSpPr>
+          <p:cNvPr id="28" name="Text 25"/>
+          <p:cNvSpPr txBox="1"/>
+          <p:nvPr/>
+        </p:nvSpPr>
+        <p:spPr>
+          <a:xfrm>
+            <a:off x="8766048" y="3154680"/>
+            <a:ext cx="1685544" cy="731520"/>
+          </a:xfrm>
+          <a:prstGeom prst="rect">
+            <a:avLst/>
+          </a:prstGeom>
+          <a:noFill/>
+          <a:ln/>
+        </p:spPr>
+        <p:txBody>
+          <a:bodyPr wrap="square" lIns="0" tIns="0" rIns="0" bIns="0" rtlCol="0" anchor="ctr"/>
+          <a:lstStyle/>
+          <a:p>
+            <a:pPr indent="0" marL="0">
+              <a:buNone/>
+            </a:pPr>
+            <a:r>
+              <a:rPr lang="en-US" sz="1800" dirty="0">
+                <a:solidFill>
+                  <a:srgbClr val="1D1D1F"/>
+                </a:solidFill>
+              </a:rPr>
+              <a:t>Eval</a:t>
+            </a:r>
+            <a:endParaRPr lang="en-US" sz="1800" dirty="0"/>
+          </a:p>
+        </p:txBody>
+      </p:sp>
+      <p:sp>
+        <p:nvSpPr>
+          <p:cNvPr id="29" name="Text 26"/>
+          <p:cNvSpPr txBox="1"/>
+          <p:nvPr/>
+        </p:nvSpPr>
+        <p:spPr>
+          <a:xfrm>
+            <a:off x="10451592" y="3154680"/>
+            <a:ext cx="1005840" cy="731520"/>
+          </a:xfrm>
+          <a:prstGeom prst="rect">
+            <a:avLst/>
+          </a:prstGeom>
+          <a:noFill/>
+          <a:ln/>
+        </p:spPr>
+        <p:txBody>
+          <a:bodyPr wrap="square" lIns="0" tIns="0" rIns="0" bIns="0" rtlCol="0" anchor="ctr"/>
+          <a:lstStyle/>
+          <a:p>
+            <a:pPr algn="r" indent="0" marL="0">
+              <a:buNone/>
+            </a:pPr>
+            <a:r>
+              <a:rPr lang="en-US" sz="1300" dirty="0">
+                <a:solidFill>
+                  <a:srgbClr val="55555B"/>
+                </a:solidFill>
+              </a:rPr>
+              <a:t>healthy</a:t>
+            </a:r>
+            <a:endParaRPr lang="en-US" sz="1300" dirty="0"/>
+          </a:p>
+        </p:txBody>
+      </p:sp>
+      <p:sp>
+        <p:nvSpPr>
+          <p:cNvPr id="30" name="Shape 27"/>
+          <p:cNvSpPr/>
+          <p:nvPr/>
+        </p:nvSpPr>
+        <p:spPr>
+          <a:xfrm>
+            <a:off x="548640" y="4160520"/>
+            <a:ext cx="11091672" cy="2011680"/>
+          </a:xfrm>
+          <a:prstGeom prst="roundRect">
+            <a:avLst>
+              <a:gd name="adj" fmla="val 4545"/>
+            </a:avLst>
+          </a:prstGeom>
+          <a:solidFill>
+            <a:srgbClr val="FFFFFF"/>
+          </a:solidFill>
+          <a:ln w="9525">
+            <a:solidFill>
+              <a:srgbClr val="D9D9DE"/>
+            </a:solidFill>
+            <a:prstDash val="solid"/>
+          </a:ln>
+          <a:effectLst>
+            <a:outerShdw sx="100000" sy="100000" kx="0" ky="0" algn="bl" rotWithShape="0" blurRad="76200" dist="12700" dir="5400000">
+              <a:srgbClr val="000000">
+                <a:alpha val="8000"/>
+              </a:srgbClr>
+            </a:outerShdw>
+          </a:effectLst>
+        </p:spPr>
+      </p:sp>
+      <p:sp>
+        <p:nvSpPr>
+          <p:cNvPr id="31" name="Text 28"/>
+          <p:cNvSpPr txBox="1"/>
+          <p:nvPr/>
+        </p:nvSpPr>
+        <p:spPr>
+          <a:xfrm>
+            <a:off x="731520" y="4297680"/>
+            <a:ext cx="10725912" cy="411480"/>
+          </a:xfrm>
+          <a:prstGeom prst="rect">
+            <a:avLst/>
+          </a:prstGeom>
+          <a:noFill/>
+          <a:ln/>
+        </p:spPr>
+        <p:txBody>
+          <a:bodyPr wrap="square" lIns="0" tIns="0" rIns="0" bIns="0" rtlCol="0" anchor="t"/>
+          <a:lstStyle/>
+          <a:p>
+            <a:pPr indent="0" marL="0">
+              <a:buNone/>
+            </a:pPr>
+            <a:r>
+              <a:rPr lang="en-US" sz="1800" b="1" dirty="0">
+                <a:solidFill>
+                  <a:srgbClr val="1D1D1F"/>
+                </a:solidFill>
+              </a:rPr>
+              <a:t>What to demo</a:t>
+            </a:r>
+            <a:endParaRPr lang="en-US" sz="1800" dirty="0"/>
+          </a:p>
+        </p:txBody>
+      </p:sp>
+      <p:sp>
+        <p:nvSpPr>
+          <p:cNvPr id="32" name="Text 29"/>
+          <p:cNvSpPr txBox="1"/>
+          <p:nvPr/>
+        </p:nvSpPr>
+        <p:spPr>
+          <a:xfrm>
+            <a:off x="731520" y="4709160"/>
+            <a:ext cx="10725912" cy="1353312"/>
+          </a:xfrm>
+          <a:prstGeom prst="rect">
+            <a:avLst/>
+          </a:prstGeom>
+          <a:noFill/>
+          <a:ln/>
+        </p:spPr>
+        <p:txBody>
+          <a:bodyPr wrap="square" lIns="0" tIns="0" rIns="0" bIns="0" rtlCol="0" anchor="t"/>
+          <a:lstStyle/>
+          <a:p>
+            <a:pPr indent="0" marL="0">
+              <a:buNone/>
+            </a:pPr>
+            <a:r>
+              <a:rPr lang="en-US" sz="1500" dirty="0">
+                <a:solidFill>
+                  <a:srgbClr val="1D1D1F"/>
+                </a:solidFill>
+              </a:rPr>
+              <a:t>Ask: "Why does itsdangerous keep SHA-1 as its default digest?" and show the cited answer and the evidence chain.</a:t>
+            </a:r>
+            <a:endParaRPr lang="en-US" sz="1500" dirty="0"/>
+          </a:p>
+          <a:p>
+            <a:pPr indent="0" marL="0">
+              <a:buNone/>
+            </a:pPr>
+            <a:r>
+              <a:rPr lang="en-US" sz="1500" dirty="0">
+                <a:solidFill>
+                  <a:srgbClr val="1D1D1F"/>
+                </a:solidFill>
+              </a:rPr>
+              <a:t>Evaluation page: the held-out run, per-mode leaderboard, and which model is best for what.</a:t>
+            </a:r>
+            <a:endParaRPr lang="en-US" sz="1500" dirty="0"/>
+          </a:p>
+          <a:p>
+            <a:pPr indent="0" marL="0">
+              <a:buNone/>
+            </a:pPr>
+            <a:r>
+              <a:rPr lang="en-US" sz="1500" dirty="0">
+                <a:solidFill>
+                  <a:srgbClr val="1D1D1F"/>
+                </a:solidFill>
+              </a:rPr>
+              <a:t>Repositories page: the three indexed repositories (demo, itsdangerous, Nexus).</a:t>
+            </a:r>
+            <a:endParaRPr lang="en-US" sz="1500" dirty="0"/>
           </a:p>
         </p:txBody>
       </p:sp>
@@ -13147,6 +13801,187 @@
             <a:fld id="{F7021451-1387-4CA6-816F-3879F97B5CBC}" type="slidenum">
               <a:rPr b="0" lang="en-US"/>
               <a:t>14</a:t>
+            </a:fld>
+            <a:endParaRPr lang="en-US"/>
+          </a:p>
+        </p:txBody>
+      </p:sp>
+    </p:spTree>
+  </p:cSld>
+  <p:clrMapOvr>
+    <a:masterClrMapping/>
+  </p:clrMapOvr>
+</p:sld>
+</file>
+
+<file path=ppt/slides/slide15.xml><?xml version="1.0" encoding="utf-8"?>
+<p:sld xmlns:a="http://schemas.openxmlformats.org/drawingml/2006/main" xmlns:r="http://schemas.openxmlformats.org/officeDocument/2006/relationships" xmlns:p="http://schemas.openxmlformats.org/presentationml/2006/main">
+  <p:cSld name="Slide 15">
+    <p:spTree>
+      <p:nvGrpSpPr>
+        <p:cNvPr id="1" name=""/>
+        <p:cNvGrpSpPr/>
+        <p:nvPr/>
+      </p:nvGrpSpPr>
+      <p:grpSpPr>
+        <a:xfrm>
+          <a:off x="0" y="0"/>
+          <a:ext cx="0" cy="0"/>
+          <a:chOff x="0" y="0"/>
+          <a:chExt cx="0" cy="0"/>
+        </a:xfrm>
+      </p:grpSpPr>
+      <p:sp>
+        <p:nvSpPr>
+          <p:cNvPr id="2" name="Text 0"/>
+          <p:cNvSpPr txBox="1"/>
+          <p:nvPr/>
+        </p:nvSpPr>
+        <p:spPr>
+          <a:xfrm>
+            <a:off x="548640" y="2194560"/>
+            <a:ext cx="11091672" cy="1188720"/>
+          </a:xfrm>
+          <a:prstGeom prst="rect">
+            <a:avLst/>
+          </a:prstGeom>
+          <a:noFill/>
+          <a:ln/>
+        </p:spPr>
+        <p:txBody>
+          <a:bodyPr wrap="square" lIns="0" tIns="0" rIns="0" bIns="0" rtlCol="0" anchor="ctr"/>
+          <a:lstStyle/>
+          <a:p>
+            <a:pPr indent="0" marL="0">
+              <a:buNone/>
+            </a:pPr>
+            <a:r>
+              <a:rPr lang="en-US" sz="6400" b="1" dirty="0">
+                <a:solidFill>
+                  <a:srgbClr val="1D1D1F"/>
+                </a:solidFill>
+              </a:rPr>
+              <a:t>Questions?</a:t>
+            </a:r>
+            <a:endParaRPr lang="en-US" sz="6400" dirty="0"/>
+          </a:p>
+        </p:txBody>
+      </p:sp>
+      <p:sp>
+        <p:nvSpPr>
+          <p:cNvPr id="3" name="Text 1"/>
+          <p:cNvSpPr txBox="1"/>
+          <p:nvPr/>
+        </p:nvSpPr>
+        <p:spPr>
+          <a:xfrm>
+            <a:off x="548640" y="3566160"/>
+            <a:ext cx="11091672" cy="457200"/>
+          </a:xfrm>
+          <a:prstGeom prst="rect">
+            <a:avLst/>
+          </a:prstGeom>
+          <a:noFill/>
+          <a:ln/>
+        </p:spPr>
+        <p:txBody>
+          <a:bodyPr wrap="square" lIns="0" tIns="0" rIns="0" bIns="0" rtlCol="0" anchor="ctr"/>
+          <a:lstStyle/>
+          <a:p>
+            <a:pPr indent="0" marL="0">
+              <a:buNone/>
+            </a:pPr>
+            <a:r>
+              <a:rPr lang="en-US" sz="2200" dirty="0">
+                <a:solidFill>
+                  <a:srgbClr val="55555B"/>
+                </a:solidFill>
+              </a:rPr>
+              <a:t>github.com/IATESPAGHETTI/Code_Origin</a:t>
+            </a:r>
+            <a:endParaRPr lang="en-US" sz="2200" dirty="0"/>
+          </a:p>
+        </p:txBody>
+      </p:sp>
+      <p:sp>
+        <p:nvSpPr>
+          <p:cNvPr id="4" name="Text 2"/>
+          <p:cNvSpPr txBox="1"/>
+          <p:nvPr/>
+        </p:nvSpPr>
+        <p:spPr>
+          <a:xfrm>
+            <a:off x="548640" y="4297680"/>
+            <a:ext cx="11091672" cy="457200"/>
+          </a:xfrm>
+          <a:prstGeom prst="rect">
+            <a:avLst/>
+          </a:prstGeom>
+          <a:noFill/>
+          <a:ln/>
+        </p:spPr>
+        <p:txBody>
+          <a:bodyPr wrap="square" lIns="0" tIns="0" rIns="0" bIns="0" rtlCol="0" anchor="ctr"/>
+          <a:lstStyle/>
+          <a:p>
+            <a:pPr indent="0" marL="0">
+              <a:buNone/>
+            </a:pPr>
+            <a:r>
+              <a:rPr lang="en-US" sz="1800" dirty="0">
+                <a:solidFill>
+                  <a:srgbClr val="0071E3"/>
+                </a:solidFill>
+              </a:rPr>
+              <a:t>We claim: supported on one real repository for 7B models, not yet general.</a:t>
+            </a:r>
+            <a:endParaRPr lang="en-US" sz="1800" dirty="0"/>
+          </a:p>
+        </p:txBody>
+      </p:sp>
+      <p:sp>
+        <p:nvSpPr>
+          <p:cNvPr id="25" name="Slide Number Placeholder 0"/>
+          <p:cNvSpPr>
+            <a:spLocks noGrp="1"/>
+          </p:cNvSpPr>
+          <p:nvPr>
+            <p:ph type="sldNum" sz="quarter" idx="4294967295"/>
+          </p:nvPr>
+        </p:nvSpPr>
+        <p:spPr>
+          <a:xfrm>
+            <a:off x="10725912" y="6419088"/>
+            <a:ext cx="914400" cy="274320"/>
+          </a:xfrm>
+          <a:prstGeom prst="rect">
+            <a:avLst/>
+          </a:prstGeom>
+          <a:extLst>
+            <a:ext uri="{C572A759-6A51-4108-AA02-DFA0A04FC94B}">
+              <ma14:wrappingTextBoxFlag xmlns:ma14="http://schemas.microsoft.com/office/mac/drawingml/2011/main" val="0"/>
+            </a:ext>
+          </a:extLst>
+        </p:spPr>
+        <p:txBody>
+          <a:bodyPr/>
+          <a:lstStyle>
+            <a:lvl1pPr>
+              <a:defRPr sz="1100">
+                <a:solidFill>
+                  <a:srgbClr val="55555B"/>
+                </a:solidFill>
+                <a:latin typeface="Calibri"/>
+                <a:ea typeface="Calibri"/>
+                <a:cs typeface="Calibri"/>
+              </a:defRPr>
+            </a:lvl1pPr>
+          </a:lstStyle>
+          <a:p>
+            <a:pPr algn="r"/>
+            <a:fld id="{F7021451-1387-4CA6-816F-3879F97B5CBC}" type="slidenum">
+              <a:rPr b="0" lang="en-US"/>
+              <a:t>15</a:t>
             </a:fld>
             <a:endParaRPr lang="en-US"/>
           </a:p>
@@ -18546,7 +19381,7 @@
                   <a:srgbClr val="55555B"/>
                 </a:solidFill>
               </a:rPr>
-              <a:t>Prometheus + Grafana + Loki, with alert rules and evaluation scores as metrics (optional profile)</a:t>
+              <a:t>Prometheus + Grafana + Loki run with the demo: live service metrics, alert rules, and evaluation scores and cost as dashboards</a:t>
             </a:r>
             <a:endParaRPr lang="en-US" sz="1500" dirty="0"/>
           </a:p>
@@ -19910,7 +20745,7 @@
                   <a:srgbClr val="0071E3"/>
                 </a:solidFill>
               </a:rPr>
-              <a:t>RESULTS: HELD-OUT RUN ON A REAL REPOSITORY</a:t>
+              <a:t>OBSERVABILITY</a:t>
             </a:r>
             <a:endParaRPr lang="en-US" sz="1200" dirty="0"/>
           </a:p>
@@ -19946,7 +20781,7 @@
                   <a:srgbClr val="1D1D1F"/>
                 </a:solidFill>
               </a:rPr>
-              <a:t>What the experiment shows</a:t>
+              <a:t>Monitoring with Prometheus and Grafana</a:t>
             </a:r>
             <a:endParaRPr lang="en-US" sz="3600" dirty="0"/>
           </a:p>
@@ -19982,78 +20817,26 @@
                   <a:srgbClr val="55555B"/>
                 </a:solidFill>
               </a:rPr>
-              <a:t>Run #8: pallets/itsdangerous, 35 questions, 399 answers, real local models. Overall correctness per mode.</a:t>
+              <a:t>Prometheus scrapes the gateway and the evaluation service every 30 seconds; Grafana shows them live, with no login.</a:t>
             </a:r>
             <a:endParaRPr lang="en-US" sz="1600" dirty="0"/>
           </a:p>
         </p:txBody>
       </p:sp>
-      <p:graphicFrame>
-        <p:nvGraphicFramePr>
-          <p:cNvPr id="6" name="Chart 0" descr=""/>
-          <p:cNvGraphicFramePr/>
-          <p:nvPr/>
-        </p:nvGraphicFramePr>
-        <p:xfrm>
-          <a:off x="548640" y="2011680"/>
-          <a:ext cx="6949440" cy="4206240"/>
-        </p:xfrm>
-        <a:graphic xmlns:a="http://schemas.openxmlformats.org/drawingml/2006/main">
-          <a:graphicData uri="http://schemas.openxmlformats.org/drawingml/2006/chart">
-            <c:chart xmlns:c="http://schemas.openxmlformats.org/drawingml/2006/chart" r:id="rId1"/>
-          </a:graphicData>
-        </a:graphic>
-      </p:graphicFrame>
-      <p:sp>
-        <p:nvSpPr>
-          <p:cNvPr id="7" name="Text 3"/>
-          <p:cNvSpPr txBox="1"/>
-          <p:nvPr/>
-        </p:nvSpPr>
-        <p:spPr>
-          <a:xfrm>
-            <a:off x="7772400" y="2011680"/>
-            <a:ext cx="3840480" cy="320040"/>
-          </a:xfrm>
-          <a:prstGeom prst="rect">
-            <a:avLst/>
-          </a:prstGeom>
-          <a:noFill/>
-          <a:ln/>
-        </p:spPr>
-        <p:txBody>
-          <a:bodyPr wrap="square" lIns="0" tIns="0" rIns="0" bIns="0" rtlCol="0" anchor="ctr"/>
-          <a:lstStyle/>
-          <a:p>
-            <a:pPr indent="0" marL="0">
-              <a:buNone/>
-            </a:pPr>
-            <a:r>
-              <a:rPr lang="en-US" sz="1400" b="1" dirty="0">
-                <a:solidFill>
-                  <a:srgbClr val="1D1D1F"/>
-                </a:solidFill>
-              </a:rPr>
-              <a:t>History vs code-only (24 history questions)</a:t>
-            </a:r>
-            <a:endParaRPr lang="en-US" sz="1400" dirty="0"/>
-          </a:p>
-        </p:txBody>
-      </p:sp>
-      <p:sp>
-        <p:nvSpPr>
-          <p:cNvPr id="8" name="Shape 4"/>
+      <p:sp>
+        <p:nvSpPr>
+          <p:cNvPr id="6" name="Shape 3"/>
           <p:cNvSpPr/>
           <p:nvPr/>
         </p:nvSpPr>
         <p:spPr>
           <a:xfrm>
-            <a:off x="7772400" y="2423160"/>
-            <a:ext cx="3867912" cy="1051560"/>
+            <a:off x="548640" y="2103120"/>
+            <a:ext cx="4114800" cy="1234440"/>
           </a:xfrm>
           <a:prstGeom prst="roundRect">
             <a:avLst>
-              <a:gd name="adj" fmla="val 8696"/>
+              <a:gd name="adj" fmla="val 7407"/>
             </a:avLst>
           </a:prstGeom>
           <a:solidFill>
@@ -20065,18 +20848,25 @@
             </a:solidFill>
             <a:prstDash val="solid"/>
           </a:ln>
-        </p:spPr>
-      </p:sp>
-      <p:sp>
-        <p:nvSpPr>
-          <p:cNvPr id="9" name="Text 5"/>
+          <a:effectLst>
+            <a:outerShdw sx="100000" sy="100000" kx="0" ky="0" algn="bl" rotWithShape="0" blurRad="76200" dist="12700" dir="5400000">
+              <a:srgbClr val="000000">
+                <a:alpha val="8000"/>
+              </a:srgbClr>
+            </a:outerShdw>
+          </a:effectLst>
+        </p:spPr>
+      </p:sp>
+      <p:sp>
+        <p:nvSpPr>
+          <p:cNvPr id="7" name="Text 4"/>
           <p:cNvSpPr txBox="1"/>
           <p:nvPr/>
         </p:nvSpPr>
         <p:spPr>
           <a:xfrm>
-            <a:off x="7955280" y="2514600"/>
-            <a:ext cx="2011680" cy="320040"/>
+            <a:off x="731520" y="2240280"/>
+            <a:ext cx="3749040" cy="292608"/>
           </a:xfrm>
           <a:prstGeom prst="rect">
             <a:avLst/>
@@ -20085,7 +20875,7 @@
           <a:ln/>
         </p:spPr>
         <p:txBody>
-          <a:bodyPr wrap="square" lIns="0" tIns="0" rIns="0" bIns="0" rtlCol="0" anchor="ctr"/>
+          <a:bodyPr wrap="square" lIns="0" tIns="0" rIns="0" bIns="0" rtlCol="0" anchor="t"/>
           <a:lstStyle/>
           <a:p>
             <a:pPr indent="0" marL="0">
@@ -20094,10 +20884,10 @@
             <a:r>
               <a:rPr lang="en-US" sz="1500" b="1" dirty="0">
                 <a:solidFill>
-                  <a:srgbClr val="1D1D1F"/>
+                  <a:srgbClr val="0071E3"/>
                 </a:solidFill>
               </a:rPr>
-              <a:t>llama2</a:t>
+              <a:t>Live service metrics</a:t>
             </a:r>
             <a:endParaRPr lang="en-US" sz="1500" dirty="0"/>
           </a:p>
@@ -20105,14 +20895,14 @@
       </p:sp>
       <p:sp>
         <p:nvSpPr>
-          <p:cNvPr id="10" name="Text 6"/>
+          <p:cNvPr id="8" name="Text 5"/>
           <p:cNvSpPr txBox="1"/>
           <p:nvPr/>
         </p:nvSpPr>
         <p:spPr>
           <a:xfrm>
-            <a:off x="9966960" y="2468880"/>
-            <a:ext cx="1554480" cy="457200"/>
+            <a:off x="731520" y="2532888"/>
+            <a:ext cx="3749040" cy="694944"/>
           </a:xfrm>
           <a:prstGeom prst="rect">
             <a:avLst/>
@@ -20121,43 +20911,7 @@
           <a:ln/>
         </p:spPr>
         <p:txBody>
-          <a:bodyPr wrap="square" lIns="0" tIns="0" rIns="0" bIns="0" rtlCol="0" anchor="ctr"/>
-          <a:lstStyle/>
-          <a:p>
-            <a:pPr algn="r" indent="0" marL="0">
-              <a:buNone/>
-            </a:pPr>
-            <a:r>
-              <a:rPr lang="en-US" sz="2400" b="1" dirty="0">
-                <a:solidFill>
-                  <a:srgbClr val="1E9E6A"/>
-                </a:solidFill>
-              </a:rPr>
-              <a:t>+0.32</a:t>
-            </a:r>
-            <a:endParaRPr lang="en-US" sz="2400" dirty="0"/>
-          </a:p>
-        </p:txBody>
-      </p:sp>
-      <p:sp>
-        <p:nvSpPr>
-          <p:cNvPr id="11" name="Text 7"/>
-          <p:cNvSpPr txBox="1"/>
-          <p:nvPr/>
-        </p:nvSpPr>
-        <p:spPr>
-          <a:xfrm>
-            <a:off x="7955280" y="2880360"/>
-            <a:ext cx="3566160" cy="274320"/>
-          </a:xfrm>
-          <a:prstGeom prst="rect">
-            <a:avLst/>
-          </a:prstGeom>
-          <a:noFill/>
-          <a:ln/>
-        </p:spPr>
-        <p:txBody>
-          <a:bodyPr wrap="square" lIns="0" tIns="0" rIns="0" bIns="0" rtlCol="0" anchor="ctr"/>
+          <a:bodyPr wrap="square" lIns="0" tIns="0" rIns="0" bIns="0" rtlCol="0" anchor="t"/>
           <a:lstStyle/>
           <a:p>
             <a:pPr indent="0" marL="0">
@@ -20169,7 +20923,7 @@
                   <a:srgbClr val="55555B"/>
                 </a:solidFill>
               </a:rPr>
-              <a:t>95% CI [+0.07, +0.55]</a:t>
+              <a:t>Requests per second, p95 latency, 5xx rate, guardrail triggers, LLM tokens, refusals, and service logs (Loki).</a:t>
             </a:r>
             <a:endParaRPr lang="en-US" sz="1200" dirty="0"/>
           </a:p>
@@ -20177,54 +20931,18 @@
       </p:sp>
       <p:sp>
         <p:nvSpPr>
-          <p:cNvPr id="12" name="Text 8"/>
-          <p:cNvSpPr txBox="1"/>
-          <p:nvPr/>
-        </p:nvSpPr>
-        <p:spPr>
-          <a:xfrm>
-            <a:off x="7955280" y="3136392"/>
-            <a:ext cx="3566160" cy="274320"/>
-          </a:xfrm>
-          <a:prstGeom prst="rect">
-            <a:avLst/>
-          </a:prstGeom>
-          <a:noFill/>
-          <a:ln/>
-        </p:spPr>
-        <p:txBody>
-          <a:bodyPr wrap="square" lIns="0" tIns="0" rIns="0" bIns="0" rtlCol="0" anchor="ctr"/>
-          <a:lstStyle/>
-          <a:p>
-            <a:pPr indent="0" marL="0">
-              <a:buNone/>
-            </a:pPr>
-            <a:r>
-              <a:rPr lang="en-US" sz="1300" b="1" dirty="0">
-                <a:solidFill>
-                  <a:srgbClr val="1E9E6A"/>
-                </a:solidFill>
-              </a:rPr>
-              <a:t>history is useful</a:t>
-            </a:r>
-            <a:endParaRPr lang="en-US" sz="1300" dirty="0"/>
-          </a:p>
-        </p:txBody>
-      </p:sp>
-      <p:sp>
-        <p:nvSpPr>
-          <p:cNvPr id="13" name="Shape 9"/>
+          <p:cNvPr id="9" name="Shape 6"/>
           <p:cNvSpPr/>
           <p:nvPr/>
         </p:nvSpPr>
         <p:spPr>
           <a:xfrm>
-            <a:off x="7772400" y="3611880"/>
-            <a:ext cx="3867912" cy="1051560"/>
+            <a:off x="548640" y="3474720"/>
+            <a:ext cx="4114800" cy="1234440"/>
           </a:xfrm>
           <a:prstGeom prst="roundRect">
             <a:avLst>
-              <a:gd name="adj" fmla="val 8696"/>
+              <a:gd name="adj" fmla="val 7407"/>
             </a:avLst>
           </a:prstGeom>
           <a:solidFill>
@@ -20236,18 +20954,25 @@
             </a:solidFill>
             <a:prstDash val="solid"/>
           </a:ln>
-        </p:spPr>
-      </p:sp>
-      <p:sp>
-        <p:nvSpPr>
-          <p:cNvPr id="14" name="Text 10"/>
+          <a:effectLst>
+            <a:outerShdw sx="100000" sy="100000" kx="0" ky="0" algn="bl" rotWithShape="0" blurRad="76200" dist="12700" dir="5400000">
+              <a:srgbClr val="000000">
+                <a:alpha val="8000"/>
+              </a:srgbClr>
+            </a:outerShdw>
+          </a:effectLst>
+        </p:spPr>
+      </p:sp>
+      <p:sp>
+        <p:nvSpPr>
+          <p:cNvPr id="10" name="Text 7"/>
           <p:cNvSpPr txBox="1"/>
           <p:nvPr/>
         </p:nvSpPr>
         <p:spPr>
           <a:xfrm>
-            <a:off x="7955280" y="3703320"/>
-            <a:ext cx="2011680" cy="320040"/>
+            <a:off x="731520" y="3611880"/>
+            <a:ext cx="3749040" cy="292608"/>
           </a:xfrm>
           <a:prstGeom prst="rect">
             <a:avLst/>
@@ -20256,7 +20981,7 @@
           <a:ln/>
         </p:spPr>
         <p:txBody>
-          <a:bodyPr wrap="square" lIns="0" tIns="0" rIns="0" bIns="0" rtlCol="0" anchor="ctr"/>
+          <a:bodyPr wrap="square" lIns="0" tIns="0" rIns="0" bIns="0" rtlCol="0" anchor="t"/>
           <a:lstStyle/>
           <a:p>
             <a:pPr indent="0" marL="0">
@@ -20265,10 +20990,10 @@
             <a:r>
               <a:rPr lang="en-US" sz="1500" b="1" dirty="0">
                 <a:solidFill>
-                  <a:srgbClr val="1D1D1F"/>
+                  <a:srgbClr val="0071E3"/>
                 </a:solidFill>
               </a:rPr>
-              <a:t>codellama:7b</a:t>
+              <a:t>Evaluation results as metrics</a:t>
             </a:r>
             <a:endParaRPr lang="en-US" sz="1500" dirty="0"/>
           </a:p>
@@ -20276,14 +21001,14 @@
       </p:sp>
       <p:sp>
         <p:nvSpPr>
-          <p:cNvPr id="15" name="Text 11"/>
+          <p:cNvPr id="11" name="Text 8"/>
           <p:cNvSpPr txBox="1"/>
           <p:nvPr/>
         </p:nvSpPr>
         <p:spPr>
           <a:xfrm>
-            <a:off x="9966960" y="3657600"/>
-            <a:ext cx="1554480" cy="457200"/>
+            <a:off x="731520" y="3904488"/>
+            <a:ext cx="3749040" cy="694944"/>
           </a:xfrm>
           <a:prstGeom prst="rect">
             <a:avLst/>
@@ -20292,43 +21017,7 @@
           <a:ln/>
         </p:spPr>
         <p:txBody>
-          <a:bodyPr wrap="square" lIns="0" tIns="0" rIns="0" bIns="0" rtlCol="0" anchor="ctr"/>
-          <a:lstStyle/>
-          <a:p>
-            <a:pPr algn="r" indent="0" marL="0">
-              <a:buNone/>
-            </a:pPr>
-            <a:r>
-              <a:rPr lang="en-US" sz="2400" b="1" dirty="0">
-                <a:solidFill>
-                  <a:srgbClr val="1E9E6A"/>
-                </a:solidFill>
-              </a:rPr>
-              <a:t>+0.28</a:t>
-            </a:r>
-            <a:endParaRPr lang="en-US" sz="2400" dirty="0"/>
-          </a:p>
-        </p:txBody>
-      </p:sp>
-      <p:sp>
-        <p:nvSpPr>
-          <p:cNvPr id="16" name="Text 12"/>
-          <p:cNvSpPr txBox="1"/>
-          <p:nvPr/>
-        </p:nvSpPr>
-        <p:spPr>
-          <a:xfrm>
-            <a:off x="7955280" y="4069080"/>
-            <a:ext cx="3566160" cy="274320"/>
-          </a:xfrm>
-          <a:prstGeom prst="rect">
-            <a:avLst/>
-          </a:prstGeom>
-          <a:noFill/>
-          <a:ln/>
-        </p:spPr>
-        <p:txBody>
-          <a:bodyPr wrap="square" lIns="0" tIns="0" rIns="0" bIns="0" rtlCol="0" anchor="ctr"/>
+          <a:bodyPr wrap="square" lIns="0" tIns="0" rIns="0" bIns="0" rtlCol="0" anchor="t"/>
           <a:lstStyle/>
           <a:p>
             <a:pPr indent="0" marL="0">
@@ -20340,7 +21029,7 @@
                   <a:srgbClr val="55555B"/>
                 </a:solidFill>
               </a:rPr>
-              <a:t>95% CI [+0.05, +0.49]</a:t>
+              <a:t>Correctness per model and mode, history effect with its 95% interval, the verdict, and the failure taxonomy, for any run.</a:t>
             </a:r>
             <a:endParaRPr lang="en-US" sz="1200" dirty="0"/>
           </a:p>
@@ -20348,54 +21037,18 @@
       </p:sp>
       <p:sp>
         <p:nvSpPr>
-          <p:cNvPr id="17" name="Text 13"/>
-          <p:cNvSpPr txBox="1"/>
-          <p:nvPr/>
-        </p:nvSpPr>
-        <p:spPr>
-          <a:xfrm>
-            <a:off x="7955280" y="4325112"/>
-            <a:ext cx="3566160" cy="274320"/>
-          </a:xfrm>
-          <a:prstGeom prst="rect">
-            <a:avLst/>
-          </a:prstGeom>
-          <a:noFill/>
-          <a:ln/>
-        </p:spPr>
-        <p:txBody>
-          <a:bodyPr wrap="square" lIns="0" tIns="0" rIns="0" bIns="0" rtlCol="0" anchor="ctr"/>
-          <a:lstStyle/>
-          <a:p>
-            <a:pPr indent="0" marL="0">
-              <a:buNone/>
-            </a:pPr>
-            <a:r>
-              <a:rPr lang="en-US" sz="1300" b="1" dirty="0">
-                <a:solidFill>
-                  <a:srgbClr val="1E9E6A"/>
-                </a:solidFill>
-              </a:rPr>
-              <a:t>history is useful</a:t>
-            </a:r>
-            <a:endParaRPr lang="en-US" sz="1300" dirty="0"/>
-          </a:p>
-        </p:txBody>
-      </p:sp>
-      <p:sp>
-        <p:nvSpPr>
-          <p:cNvPr id="18" name="Shape 14"/>
+          <p:cNvPr id="12" name="Shape 9"/>
           <p:cNvSpPr/>
           <p:nvPr/>
         </p:nvSpPr>
         <p:spPr>
           <a:xfrm>
-            <a:off x="7772400" y="4800600"/>
-            <a:ext cx="3867912" cy="1051560"/>
+            <a:off x="548640" y="4846320"/>
+            <a:ext cx="4114800" cy="1234440"/>
           </a:xfrm>
           <a:prstGeom prst="roundRect">
             <a:avLst>
-              <a:gd name="adj" fmla="val 8696"/>
+              <a:gd name="adj" fmla="val 7407"/>
             </a:avLst>
           </a:prstGeom>
           <a:solidFill>
@@ -20407,18 +21060,25 @@
             </a:solidFill>
             <a:prstDash val="solid"/>
           </a:ln>
-        </p:spPr>
-      </p:sp>
-      <p:sp>
-        <p:nvSpPr>
-          <p:cNvPr id="19" name="Text 15"/>
+          <a:effectLst>
+            <a:outerShdw sx="100000" sy="100000" kx="0" ky="0" algn="bl" rotWithShape="0" blurRad="76200" dist="12700" dir="5400000">
+              <a:srgbClr val="000000">
+                <a:alpha val="8000"/>
+              </a:srgbClr>
+            </a:outerShdw>
+          </a:effectLst>
+        </p:spPr>
+      </p:sp>
+      <p:sp>
+        <p:nvSpPr>
+          <p:cNvPr id="13" name="Text 10"/>
           <p:cNvSpPr txBox="1"/>
           <p:nvPr/>
         </p:nvSpPr>
         <p:spPr>
           <a:xfrm>
-            <a:off x="7955280" y="4892040"/>
-            <a:ext cx="2011680" cy="320040"/>
+            <a:off x="731520" y="4983480"/>
+            <a:ext cx="3749040" cy="292608"/>
           </a:xfrm>
           <a:prstGeom prst="rect">
             <a:avLst/>
@@ -20427,7 +21087,7 @@
           <a:ln/>
         </p:spPr>
         <p:txBody>
-          <a:bodyPr wrap="square" lIns="0" tIns="0" rIns="0" bIns="0" rtlCol="0" anchor="ctr"/>
+          <a:bodyPr wrap="square" lIns="0" tIns="0" rIns="0" bIns="0" rtlCol="0" anchor="t"/>
           <a:lstStyle/>
           <a:p>
             <a:pPr indent="0" marL="0">
@@ -20436,10 +21096,10 @@
             <a:r>
               <a:rPr lang="en-US" sz="1500" b="1" dirty="0">
                 <a:solidFill>
-                  <a:srgbClr val="1D1D1F"/>
+                  <a:srgbClr val="0071E3"/>
                 </a:solidFill>
               </a:rPr>
-              <a:t>starcoder2:3b</a:t>
+              <a:t>Quality and cost</a:t>
             </a:r>
             <a:endParaRPr lang="en-US" sz="1500" dirty="0"/>
           </a:p>
@@ -20447,14 +21107,14 @@
       </p:sp>
       <p:sp>
         <p:nvSpPr>
-          <p:cNvPr id="20" name="Text 16"/>
+          <p:cNvPr id="14" name="Text 11"/>
           <p:cNvSpPr txBox="1"/>
           <p:nvPr/>
         </p:nvSpPr>
         <p:spPr>
           <a:xfrm>
-            <a:off x="9966960" y="4846320"/>
-            <a:ext cx="1554480" cy="457200"/>
+            <a:off x="731520" y="5276088"/>
+            <a:ext cx="3749040" cy="694944"/>
           </a:xfrm>
           <a:prstGeom prst="rect">
             <a:avLst/>
@@ -20463,43 +21123,7 @@
           <a:ln/>
         </p:spPr>
         <p:txBody>
-          <a:bodyPr wrap="square" lIns="0" tIns="0" rIns="0" bIns="0" rtlCol="0" anchor="ctr"/>
-          <a:lstStyle/>
-          <a:p>
-            <a:pPr algn="r" indent="0" marL="0">
-              <a:buNone/>
-            </a:pPr>
-            <a:r>
-              <a:rPr lang="en-US" sz="2400" b="1" dirty="0">
-                <a:solidFill>
-                  <a:srgbClr val="55555B"/>
-                </a:solidFill>
-              </a:rPr>
-              <a:t>−0.02</a:t>
-            </a:r>
-            <a:endParaRPr lang="en-US" sz="2400" dirty="0"/>
-          </a:p>
-        </p:txBody>
-      </p:sp>
-      <p:sp>
-        <p:nvSpPr>
-          <p:cNvPr id="21" name="Text 17"/>
-          <p:cNvSpPr txBox="1"/>
-          <p:nvPr/>
-        </p:nvSpPr>
-        <p:spPr>
-          <a:xfrm>
-            <a:off x="7955280" y="5257800"/>
-            <a:ext cx="3566160" cy="274320"/>
-          </a:xfrm>
-          <a:prstGeom prst="rect">
-            <a:avLst/>
-          </a:prstGeom>
-          <a:noFill/>
-          <a:ln/>
-        </p:spPr>
-        <p:txBody>
-          <a:bodyPr wrap="square" lIns="0" tIns="0" rIns="0" bIns="0" rtlCol="0" anchor="ctr"/>
+          <a:bodyPr wrap="square" lIns="0" tIns="0" rIns="0" bIns="0" rtlCol="0" anchor="t"/>
           <a:lstStyle/>
           <a:p>
             <a:pPr indent="0" marL="0">
@@ -20511,7 +21135,7 @@
                   <a:srgbClr val="55555B"/>
                 </a:solidFill>
               </a:rPr>
-              <a:t>95% CI [−0.21, +0.17]</a:t>
+              <a:t>Hallucination rate 31% / 22% / 59%, retrieval recall 0.14 to 0.70 to 1.00, latency and tokens per model.</a:t>
             </a:r>
             <a:endParaRPr lang="en-US" sz="1200" dirty="0"/>
           </a:p>
@@ -20519,40 +21143,55 @@
       </p:sp>
       <p:sp>
         <p:nvSpPr>
-          <p:cNvPr id="22" name="Text 18"/>
-          <p:cNvSpPr txBox="1"/>
-          <p:nvPr/>
-        </p:nvSpPr>
-        <p:spPr>
-          <a:xfrm>
-            <a:off x="7955280" y="5513832"/>
-            <a:ext cx="3566160" cy="274320"/>
+          <p:cNvPr id="15" name="Shape 12"/>
+          <p:cNvSpPr/>
+          <p:nvPr/>
+        </p:nvSpPr>
+        <p:spPr>
+          <a:xfrm>
+            <a:off x="4937760" y="2103120"/>
+            <a:ext cx="6702552" cy="4160520"/>
+          </a:xfrm>
+          <a:prstGeom prst="roundRect">
+            <a:avLst>
+              <a:gd name="adj" fmla="val 1758"/>
+            </a:avLst>
+          </a:prstGeom>
+          <a:solidFill>
+            <a:srgbClr val="FFFFFF"/>
+          </a:solidFill>
+          <a:ln w="9525">
+            <a:solidFill>
+              <a:srgbClr val="D9D9DE"/>
+            </a:solidFill>
+            <a:prstDash val="solid"/>
+          </a:ln>
+        </p:spPr>
+      </p:sp>
+      <p:pic>
+        <p:nvPicPr>
+          <p:cNvPr id="16" name="Image 0" descr="Grafana panels: hallucination rate, retrieval quality, latency, tokens per answer">    </p:cNvPr>
+          <p:cNvPicPr>
+            <a:picLocks noChangeAspect="1"/>
+          </p:cNvPicPr>
+          <p:nvPr/>
+        </p:nvPicPr>
+        <p:blipFill>
+          <a:blip r:embed="rId1"/>
+          <a:stretch>
+            <a:fillRect/>
+          </a:stretch>
+        </p:blipFill>
+        <p:spPr>
+          <a:xfrm>
+            <a:off x="5029200" y="2194560"/>
+            <a:ext cx="6519672" cy="4074566"/>
           </a:xfrm>
           <a:prstGeom prst="rect">
             <a:avLst/>
           </a:prstGeom>
-          <a:noFill/>
-          <a:ln/>
-        </p:spPr>
-        <p:txBody>
-          <a:bodyPr wrap="square" lIns="0" tIns="0" rIns="0" bIns="0" rtlCol="0" anchor="ctr"/>
-          <a:lstStyle/>
-          <a:p>
-            <a:pPr indent="0" marL="0">
-              <a:buNone/>
-            </a:pPr>
-            <a:r>
-              <a:rPr lang="en-US" sz="1300" b="1" dirty="0">
-                <a:solidFill>
-                  <a:srgbClr val="55555B"/>
-                </a:solidFill>
-              </a:rPr>
-              <a:t>no effect detected</a:t>
-            </a:r>
-            <a:endParaRPr lang="en-US" sz="1300" dirty="0"/>
-          </a:p>
-        </p:txBody>
-      </p:sp>
+        </p:spPr>
+      </p:pic>
       <p:sp>
         <p:nvSpPr>
           <p:cNvPr id="25" name="Slide Number Placeholder 0"/>

</xml_diff>